<commit_message>
Update description of Information Structure
</commit_message>
<xml_diff>
--- a/spec/Diagrams/InformationStructure/InformationStructure.pptx
+++ b/spec/Diagrams/InformationStructure/InformationStructure.pptx
@@ -5,10 +5,11 @@
     <p:sldMasterId id="2147483732" r:id="rId1"/>
   </p:sldMasterIdLst>
   <p:notesMasterIdLst>
-    <p:notesMasterId r:id="rId3"/>
+    <p:notesMasterId r:id="rId4"/>
   </p:notesMasterIdLst>
   <p:sldIdLst>
     <p:sldId id="302" r:id="rId2"/>
+    <p:sldId id="303" r:id="rId3"/>
   </p:sldIdLst>
   <p:sldSz cx="23399750" cy="18000663"/>
   <p:notesSz cx="6858000" cy="9144000"/>
@@ -197,7 +198,7 @@
           <a:p>
             <a:fld id="{37CCF725-7468-4D3D-9E24-A16745BBBA77}" type="datetimeFigureOut">
               <a:rPr lang="de-DE" smtClean="0"/>
-              <a:t>29.04.2025</a:t>
+              <a:t>30.04.2025</a:t>
             </a:fld>
             <a:endParaRPr lang="de-DE"/>
           </a:p>
@@ -595,7 +596,7 @@
           <a:p>
             <a:fld id="{9A2764DB-E7DF-4EA7-A1AF-05A77C280FCA}" type="datetimeFigureOut">
               <a:rPr lang="de-DE" smtClean="0"/>
-              <a:t>29.04.2025</a:t>
+              <a:t>30.04.2025</a:t>
             </a:fld>
             <a:endParaRPr lang="de-DE"/>
           </a:p>
@@ -765,7 +766,7 @@
           <a:p>
             <a:fld id="{9A2764DB-E7DF-4EA7-A1AF-05A77C280FCA}" type="datetimeFigureOut">
               <a:rPr lang="de-DE" smtClean="0"/>
-              <a:t>29.04.2025</a:t>
+              <a:t>30.04.2025</a:t>
             </a:fld>
             <a:endParaRPr lang="de-DE"/>
           </a:p>
@@ -945,7 +946,7 @@
           <a:p>
             <a:fld id="{9A2764DB-E7DF-4EA7-A1AF-05A77C280FCA}" type="datetimeFigureOut">
               <a:rPr lang="de-DE" smtClean="0"/>
-              <a:t>29.04.2025</a:t>
+              <a:t>30.04.2025</a:t>
             </a:fld>
             <a:endParaRPr lang="de-DE"/>
           </a:p>
@@ -1115,7 +1116,7 @@
           <a:p>
             <a:fld id="{9A2764DB-E7DF-4EA7-A1AF-05A77C280FCA}" type="datetimeFigureOut">
               <a:rPr lang="de-DE" smtClean="0"/>
-              <a:t>29.04.2025</a:t>
+              <a:t>30.04.2025</a:t>
             </a:fld>
             <a:endParaRPr lang="de-DE"/>
           </a:p>
@@ -1361,7 +1362,7 @@
           <a:p>
             <a:fld id="{9A2764DB-E7DF-4EA7-A1AF-05A77C280FCA}" type="datetimeFigureOut">
               <a:rPr lang="de-DE" smtClean="0"/>
-              <a:t>29.04.2025</a:t>
+              <a:t>30.04.2025</a:t>
             </a:fld>
             <a:endParaRPr lang="de-DE"/>
           </a:p>
@@ -1593,7 +1594,7 @@
           <a:p>
             <a:fld id="{9A2764DB-E7DF-4EA7-A1AF-05A77C280FCA}" type="datetimeFigureOut">
               <a:rPr lang="de-DE" smtClean="0"/>
-              <a:t>29.04.2025</a:t>
+              <a:t>30.04.2025</a:t>
             </a:fld>
             <a:endParaRPr lang="de-DE"/>
           </a:p>
@@ -1960,7 +1961,7 @@
           <a:p>
             <a:fld id="{9A2764DB-E7DF-4EA7-A1AF-05A77C280FCA}" type="datetimeFigureOut">
               <a:rPr lang="de-DE" smtClean="0"/>
-              <a:t>29.04.2025</a:t>
+              <a:t>30.04.2025</a:t>
             </a:fld>
             <a:endParaRPr lang="de-DE"/>
           </a:p>
@@ -2078,7 +2079,7 @@
           <a:p>
             <a:fld id="{9A2764DB-E7DF-4EA7-A1AF-05A77C280FCA}" type="datetimeFigureOut">
               <a:rPr lang="de-DE" smtClean="0"/>
-              <a:t>29.04.2025</a:t>
+              <a:t>30.04.2025</a:t>
             </a:fld>
             <a:endParaRPr lang="de-DE"/>
           </a:p>
@@ -2173,7 +2174,7 @@
           <a:p>
             <a:fld id="{9A2764DB-E7DF-4EA7-A1AF-05A77C280FCA}" type="datetimeFigureOut">
               <a:rPr lang="de-DE" smtClean="0"/>
-              <a:t>29.04.2025</a:t>
+              <a:t>30.04.2025</a:t>
             </a:fld>
             <a:endParaRPr lang="de-DE"/>
           </a:p>
@@ -2450,7 +2451,7 @@
           <a:p>
             <a:fld id="{9A2764DB-E7DF-4EA7-A1AF-05A77C280FCA}" type="datetimeFigureOut">
               <a:rPr lang="de-DE" smtClean="0"/>
-              <a:t>29.04.2025</a:t>
+              <a:t>30.04.2025</a:t>
             </a:fld>
             <a:endParaRPr lang="de-DE"/>
           </a:p>
@@ -2707,7 +2708,7 @@
           <a:p>
             <a:fld id="{9A2764DB-E7DF-4EA7-A1AF-05A77C280FCA}" type="datetimeFigureOut">
               <a:rPr lang="de-DE" smtClean="0"/>
-              <a:t>29.04.2025</a:t>
+              <a:t>30.04.2025</a:t>
             </a:fld>
             <a:endParaRPr lang="de-DE"/>
           </a:p>
@@ -2920,7 +2921,7 @@
           <a:p>
             <a:fld id="{9A2764DB-E7DF-4EA7-A1AF-05A77C280FCA}" type="datetimeFigureOut">
               <a:rPr lang="de-DE" smtClean="0"/>
-              <a:t>29.04.2025</a:t>
+              <a:t>30.04.2025</a:t>
             </a:fld>
             <a:endParaRPr lang="de-DE"/>
           </a:p>
@@ -7170,6 +7171,1803 @@
     <p:extLst>
       <p:ext uri="{BB962C8B-B14F-4D97-AF65-F5344CB8AC3E}">
         <p14:creationId xmlns:p14="http://schemas.microsoft.com/office/powerpoint/2010/main" val="1618497423"/>
+      </p:ext>
+    </p:extLst>
+  </p:cSld>
+  <p:clrMapOvr>
+    <a:masterClrMapping/>
+  </p:clrMapOvr>
+</p:sld>
+</file>
+
+<file path=ppt/slides/slide2.xml><?xml version="1.0" encoding="utf-8"?>
+<p:sld xmlns:a="http://schemas.openxmlformats.org/drawingml/2006/main" xmlns:r="http://schemas.openxmlformats.org/officeDocument/2006/relationships" xmlns:p="http://schemas.openxmlformats.org/presentationml/2006/main">
+  <p:cSld>
+    <p:spTree>
+      <p:nvGrpSpPr>
+        <p:cNvPr id="1" name=""/>
+        <p:cNvGrpSpPr/>
+        <p:nvPr/>
+      </p:nvGrpSpPr>
+      <p:grpSpPr>
+        <a:xfrm>
+          <a:off x="0" y="0"/>
+          <a:ext cx="0" cy="0"/>
+          <a:chOff x="0" y="0"/>
+          <a:chExt cx="0" cy="0"/>
+        </a:xfrm>
+      </p:grpSpPr>
+      <p:sp>
+        <p:nvSpPr>
+          <p:cNvPr id="2" name="Textfeld 1">
+            <a:extLst>
+              <a:ext uri="{FF2B5EF4-FFF2-40B4-BE49-F238E27FC236}">
+                <a16:creationId xmlns:a16="http://schemas.microsoft.com/office/drawing/2014/main" id="{6ADAE2AF-3BC3-B985-466C-CCCF136C0C4D}"/>
+              </a:ext>
+            </a:extLst>
+          </p:cNvPr>
+          <p:cNvSpPr txBox="1"/>
+          <p:nvPr/>
+        </p:nvSpPr>
+        <p:spPr>
+          <a:xfrm>
+            <a:off x="821635" y="808383"/>
+            <a:ext cx="999248" cy="369332"/>
+          </a:xfrm>
+          <a:prstGeom prst="rect">
+            <a:avLst/>
+          </a:prstGeom>
+          <a:noFill/>
+        </p:spPr>
+        <p:txBody>
+          <a:bodyPr wrap="none" rtlCol="0">
+            <a:spAutoFit/>
+          </a:bodyPr>
+          <a:lstStyle/>
+          <a:p>
+            <a:r>
+              <a:rPr lang="de-DE"/>
+              <a:t>Running</a:t>
+            </a:r>
+          </a:p>
+        </p:txBody>
+      </p:sp>
+      <p:sp>
+        <p:nvSpPr>
+          <p:cNvPr id="4" name="Abgerundetes Rechteck 1">
+            <a:extLst>
+              <a:ext uri="{FF2B5EF4-FFF2-40B4-BE49-F238E27FC236}">
+                <a16:creationId xmlns:a16="http://schemas.microsoft.com/office/drawing/2014/main" id="{097003FE-453E-AC0E-A4B5-B46C5038573A}"/>
+              </a:ext>
+            </a:extLst>
+          </p:cNvPr>
+          <p:cNvSpPr/>
+          <p:nvPr/>
+        </p:nvSpPr>
+        <p:spPr>
+          <a:xfrm>
+            <a:off x="1052609" y="1544015"/>
+            <a:ext cx="537299" cy="445572"/>
+          </a:xfrm>
+          <a:prstGeom prst="roundRect">
+            <a:avLst/>
+          </a:prstGeom>
+          <a:solidFill>
+            <a:sysClr val="window" lastClr="FFFFFF">
+              <a:lumMod val="65000"/>
+            </a:sysClr>
+          </a:solidFill>
+          <a:ln w="12700" cap="flat" cmpd="sng" algn="ctr">
+            <a:solidFill>
+              <a:sysClr val="window" lastClr="FFFFFF">
+                <a:lumMod val="50000"/>
+              </a:sysClr>
+            </a:solidFill>
+            <a:prstDash val="solid"/>
+            <a:miter lim="800000"/>
+          </a:ln>
+          <a:effectLst>
+            <a:outerShdw blurRad="50800" dist="38100" dir="2700000" algn="tl" rotWithShape="0">
+              <a:prstClr val="black">
+                <a:alpha val="40000"/>
+              </a:prstClr>
+            </a:outerShdw>
+          </a:effectLst>
+        </p:spPr>
+        <p:txBody>
+          <a:bodyPr rtlCol="0" anchor="ctr"/>
+          <a:lstStyle/>
+          <a:p>
+            <a:pPr algn="ctr" defTabSz="914400">
+              <a:defRPr/>
+            </a:pPr>
+            <a:r>
+              <a:rPr lang="de-DE" sz="1050" kern="0" dirty="0">
+                <a:solidFill>
+                  <a:prstClr val="white"/>
+                </a:solidFill>
+                <a:latin typeface="Calibri" panose="020F0502020204030204"/>
+              </a:rPr>
+              <a:t>CC</a:t>
+            </a:r>
+          </a:p>
+        </p:txBody>
+      </p:sp>
+      <p:sp>
+        <p:nvSpPr>
+          <p:cNvPr id="5" name="Abgerundetes Rechteck 89">
+            <a:extLst>
+              <a:ext uri="{FF2B5EF4-FFF2-40B4-BE49-F238E27FC236}">
+                <a16:creationId xmlns:a16="http://schemas.microsoft.com/office/drawing/2014/main" id="{A73EEBF5-20C9-6DC9-1197-BEB3C18B3BC2}"/>
+              </a:ext>
+            </a:extLst>
+          </p:cNvPr>
+          <p:cNvSpPr/>
+          <p:nvPr/>
+        </p:nvSpPr>
+        <p:spPr>
+          <a:xfrm>
+            <a:off x="2366379" y="1544015"/>
+            <a:ext cx="1161453" cy="445572"/>
+          </a:xfrm>
+          <a:prstGeom prst="roundRect">
+            <a:avLst/>
+          </a:prstGeom>
+          <a:solidFill>
+            <a:srgbClr val="4472C4">
+              <a:lumMod val="60000"/>
+              <a:lumOff val="40000"/>
+            </a:srgbClr>
+          </a:solidFill>
+          <a:ln w="12700" cap="flat" cmpd="sng" algn="ctr">
+            <a:solidFill>
+              <a:srgbClr val="4472C4">
+                <a:lumMod val="75000"/>
+              </a:srgbClr>
+            </a:solidFill>
+            <a:prstDash val="solid"/>
+            <a:miter lim="800000"/>
+          </a:ln>
+          <a:effectLst>
+            <a:outerShdw blurRad="50800" dist="38100" dir="2700000" algn="tl" rotWithShape="0">
+              <a:prstClr val="black">
+                <a:alpha val="40000"/>
+              </a:prstClr>
+            </a:outerShdw>
+          </a:effectLst>
+        </p:spPr>
+        <p:txBody>
+          <a:bodyPr rtlCol="0" anchor="ctr"/>
+          <a:lstStyle/>
+          <a:p>
+            <a:pPr algn="ctr" defTabSz="914400">
+              <a:defRPr/>
+            </a:pPr>
+            <a:r>
+              <a:rPr lang="de-DE" sz="1050" kern="0">
+                <a:solidFill>
+                  <a:prstClr val="white"/>
+                </a:solidFill>
+                <a:latin typeface="Calibri" panose="020F0502020204030204"/>
+              </a:rPr>
+              <a:t>AirInterface #1</a:t>
+            </a:r>
+          </a:p>
+        </p:txBody>
+      </p:sp>
+      <p:sp>
+        <p:nvSpPr>
+          <p:cNvPr id="6" name="Abgerundetes Rechteck 89">
+            <a:extLst>
+              <a:ext uri="{FF2B5EF4-FFF2-40B4-BE49-F238E27FC236}">
+                <a16:creationId xmlns:a16="http://schemas.microsoft.com/office/drawing/2014/main" id="{D63C9685-F3F2-8E04-C177-78A3FE8378C5}"/>
+              </a:ext>
+            </a:extLst>
+          </p:cNvPr>
+          <p:cNvSpPr/>
+          <p:nvPr/>
+        </p:nvSpPr>
+        <p:spPr>
+          <a:xfrm>
+            <a:off x="2366379" y="2312641"/>
+            <a:ext cx="1161453" cy="445572"/>
+          </a:xfrm>
+          <a:prstGeom prst="roundRect">
+            <a:avLst/>
+          </a:prstGeom>
+          <a:solidFill>
+            <a:srgbClr val="4472C4">
+              <a:lumMod val="60000"/>
+              <a:lumOff val="40000"/>
+            </a:srgbClr>
+          </a:solidFill>
+          <a:ln w="12700" cap="flat" cmpd="sng" algn="ctr">
+            <a:solidFill>
+              <a:srgbClr val="4472C4">
+                <a:lumMod val="75000"/>
+              </a:srgbClr>
+            </a:solidFill>
+            <a:prstDash val="solid"/>
+            <a:miter lim="800000"/>
+          </a:ln>
+          <a:effectLst>
+            <a:outerShdw blurRad="50800" dist="38100" dir="2700000" algn="tl" rotWithShape="0">
+              <a:prstClr val="black">
+                <a:alpha val="40000"/>
+              </a:prstClr>
+            </a:outerShdw>
+          </a:effectLst>
+        </p:spPr>
+        <p:txBody>
+          <a:bodyPr rtlCol="0" anchor="ctr"/>
+          <a:lstStyle/>
+          <a:p>
+            <a:pPr algn="ctr" defTabSz="914400">
+              <a:defRPr/>
+            </a:pPr>
+            <a:r>
+              <a:rPr lang="de-DE" sz="1050" kern="0">
+                <a:solidFill>
+                  <a:prstClr val="white"/>
+                </a:solidFill>
+                <a:latin typeface="Calibri" panose="020F0502020204030204"/>
+              </a:rPr>
+              <a:t>AirInterface #2</a:t>
+            </a:r>
+          </a:p>
+        </p:txBody>
+      </p:sp>
+      <p:cxnSp>
+        <p:nvCxnSpPr>
+          <p:cNvPr id="8" name="Gerader Verbinder 7">
+            <a:extLst>
+              <a:ext uri="{FF2B5EF4-FFF2-40B4-BE49-F238E27FC236}">
+                <a16:creationId xmlns:a16="http://schemas.microsoft.com/office/drawing/2014/main" id="{ED36A46A-7808-A295-096B-5F9A7202D1D0}"/>
+              </a:ext>
+            </a:extLst>
+          </p:cNvPr>
+          <p:cNvCxnSpPr>
+            <a:stCxn id="4" idx="3"/>
+            <a:endCxn id="5" idx="1"/>
+          </p:cNvCxnSpPr>
+          <p:nvPr/>
+        </p:nvCxnSpPr>
+        <p:spPr>
+          <a:xfrm>
+            <a:off x="1589908" y="1766801"/>
+            <a:ext cx="776471" cy="0"/>
+          </a:xfrm>
+          <a:prstGeom prst="line">
+            <a:avLst/>
+          </a:prstGeom>
+          <a:ln>
+            <a:prstDash val="dash"/>
+          </a:ln>
+        </p:spPr>
+        <p:style>
+          <a:lnRef idx="2">
+            <a:schemeClr val="accent1"/>
+          </a:lnRef>
+          <a:fillRef idx="0">
+            <a:schemeClr val="accent1"/>
+          </a:fillRef>
+          <a:effectRef idx="1">
+            <a:schemeClr val="accent1"/>
+          </a:effectRef>
+          <a:fontRef idx="minor">
+            <a:schemeClr val="tx1"/>
+          </a:fontRef>
+        </p:style>
+      </p:cxnSp>
+      <p:cxnSp>
+        <p:nvCxnSpPr>
+          <p:cNvPr id="9" name="Gerader Verbinder 8">
+            <a:extLst>
+              <a:ext uri="{FF2B5EF4-FFF2-40B4-BE49-F238E27FC236}">
+                <a16:creationId xmlns:a16="http://schemas.microsoft.com/office/drawing/2014/main" id="{4A75D0C9-0AFC-826C-4E93-E0C9EDDE277B}"/>
+              </a:ext>
+            </a:extLst>
+          </p:cNvPr>
+          <p:cNvCxnSpPr>
+            <a:cxnSpLocks/>
+            <a:stCxn id="4" idx="3"/>
+            <a:endCxn id="6" idx="1"/>
+          </p:cNvCxnSpPr>
+          <p:nvPr/>
+        </p:nvCxnSpPr>
+        <p:spPr>
+          <a:xfrm>
+            <a:off x="1589908" y="1766801"/>
+            <a:ext cx="776471" cy="768626"/>
+          </a:xfrm>
+          <a:prstGeom prst="line">
+            <a:avLst/>
+          </a:prstGeom>
+          <a:ln>
+            <a:prstDash val="dash"/>
+          </a:ln>
+        </p:spPr>
+        <p:style>
+          <a:lnRef idx="2">
+            <a:schemeClr val="accent1"/>
+          </a:lnRef>
+          <a:fillRef idx="0">
+            <a:schemeClr val="accent1"/>
+          </a:fillRef>
+          <a:effectRef idx="1">
+            <a:schemeClr val="accent1"/>
+          </a:effectRef>
+          <a:fontRef idx="minor">
+            <a:schemeClr val="tx1"/>
+          </a:fontRef>
+        </p:style>
+      </p:cxnSp>
+      <p:sp>
+        <p:nvSpPr>
+          <p:cNvPr id="21" name="Abgerundetes Rechteck 1">
+            <a:extLst>
+              <a:ext uri="{FF2B5EF4-FFF2-40B4-BE49-F238E27FC236}">
+                <a16:creationId xmlns:a16="http://schemas.microsoft.com/office/drawing/2014/main" id="{2F4BDD46-8FE1-E9EE-4668-7A5E0F5811DC}"/>
+              </a:ext>
+            </a:extLst>
+          </p:cNvPr>
+          <p:cNvSpPr/>
+          <p:nvPr/>
+        </p:nvSpPr>
+        <p:spPr>
+          <a:xfrm>
+            <a:off x="7215284" y="1544015"/>
+            <a:ext cx="537299" cy="445572"/>
+          </a:xfrm>
+          <a:prstGeom prst="roundRect">
+            <a:avLst/>
+          </a:prstGeom>
+          <a:solidFill>
+            <a:sysClr val="window" lastClr="FFFFFF">
+              <a:lumMod val="65000"/>
+            </a:sysClr>
+          </a:solidFill>
+          <a:ln w="12700" cap="flat" cmpd="sng" algn="ctr">
+            <a:solidFill>
+              <a:sysClr val="window" lastClr="FFFFFF">
+                <a:lumMod val="50000"/>
+              </a:sysClr>
+            </a:solidFill>
+            <a:prstDash val="solid"/>
+            <a:miter lim="800000"/>
+          </a:ln>
+          <a:effectLst>
+            <a:outerShdw blurRad="50800" dist="38100" dir="2700000" algn="tl" rotWithShape="0">
+              <a:prstClr val="black">
+                <a:alpha val="40000"/>
+              </a:prstClr>
+            </a:outerShdw>
+          </a:effectLst>
+        </p:spPr>
+        <p:txBody>
+          <a:bodyPr rtlCol="0" anchor="ctr"/>
+          <a:lstStyle/>
+          <a:p>
+            <a:pPr algn="ctr" defTabSz="914400">
+              <a:defRPr/>
+            </a:pPr>
+            <a:r>
+              <a:rPr lang="de-DE" sz="1050" kern="0" dirty="0">
+                <a:solidFill>
+                  <a:prstClr val="white"/>
+                </a:solidFill>
+                <a:latin typeface="Calibri" panose="020F0502020204030204"/>
+              </a:rPr>
+              <a:t>CC</a:t>
+            </a:r>
+          </a:p>
+        </p:txBody>
+      </p:sp>
+      <p:sp>
+        <p:nvSpPr>
+          <p:cNvPr id="22" name="Abgerundetes Rechteck 89">
+            <a:extLst>
+              <a:ext uri="{FF2B5EF4-FFF2-40B4-BE49-F238E27FC236}">
+                <a16:creationId xmlns:a16="http://schemas.microsoft.com/office/drawing/2014/main" id="{AF828BBC-FDF8-3379-5936-D4C8B43EDF10}"/>
+              </a:ext>
+            </a:extLst>
+          </p:cNvPr>
+          <p:cNvSpPr/>
+          <p:nvPr/>
+        </p:nvSpPr>
+        <p:spPr>
+          <a:xfrm>
+            <a:off x="5261979" y="1544015"/>
+            <a:ext cx="1161453" cy="445572"/>
+          </a:xfrm>
+          <a:prstGeom prst="roundRect">
+            <a:avLst/>
+          </a:prstGeom>
+          <a:solidFill>
+            <a:srgbClr val="4472C4">
+              <a:lumMod val="60000"/>
+              <a:lumOff val="40000"/>
+            </a:srgbClr>
+          </a:solidFill>
+          <a:ln w="12700" cap="flat" cmpd="sng" algn="ctr">
+            <a:solidFill>
+              <a:srgbClr val="4472C4">
+                <a:lumMod val="75000"/>
+              </a:srgbClr>
+            </a:solidFill>
+            <a:prstDash val="solid"/>
+            <a:miter lim="800000"/>
+          </a:ln>
+          <a:effectLst>
+            <a:outerShdw blurRad="50800" dist="38100" dir="2700000" algn="tl" rotWithShape="0">
+              <a:prstClr val="black">
+                <a:alpha val="40000"/>
+              </a:prstClr>
+            </a:outerShdw>
+          </a:effectLst>
+        </p:spPr>
+        <p:txBody>
+          <a:bodyPr rtlCol="0" anchor="ctr"/>
+          <a:lstStyle/>
+          <a:p>
+            <a:pPr algn="ctr" defTabSz="914400">
+              <a:defRPr/>
+            </a:pPr>
+            <a:r>
+              <a:rPr lang="de-DE" sz="1050" kern="0">
+                <a:solidFill>
+                  <a:prstClr val="white"/>
+                </a:solidFill>
+                <a:latin typeface="Calibri" panose="020F0502020204030204"/>
+              </a:rPr>
+              <a:t>AirInterface #1</a:t>
+            </a:r>
+          </a:p>
+        </p:txBody>
+      </p:sp>
+      <p:sp>
+        <p:nvSpPr>
+          <p:cNvPr id="23" name="Abgerundetes Rechteck 89">
+            <a:extLst>
+              <a:ext uri="{FF2B5EF4-FFF2-40B4-BE49-F238E27FC236}">
+                <a16:creationId xmlns:a16="http://schemas.microsoft.com/office/drawing/2014/main" id="{60C35A7C-1F33-05C5-F673-9127704DC48A}"/>
+              </a:ext>
+            </a:extLst>
+          </p:cNvPr>
+          <p:cNvSpPr/>
+          <p:nvPr/>
+        </p:nvSpPr>
+        <p:spPr>
+          <a:xfrm>
+            <a:off x="5261979" y="2312641"/>
+            <a:ext cx="1161453" cy="445572"/>
+          </a:xfrm>
+          <a:prstGeom prst="roundRect">
+            <a:avLst/>
+          </a:prstGeom>
+          <a:solidFill>
+            <a:srgbClr val="4472C4">
+              <a:lumMod val="60000"/>
+              <a:lumOff val="40000"/>
+            </a:srgbClr>
+          </a:solidFill>
+          <a:ln w="12700" cap="flat" cmpd="sng" algn="ctr">
+            <a:solidFill>
+              <a:srgbClr val="4472C4">
+                <a:lumMod val="75000"/>
+              </a:srgbClr>
+            </a:solidFill>
+            <a:prstDash val="solid"/>
+            <a:miter lim="800000"/>
+          </a:ln>
+          <a:effectLst>
+            <a:outerShdw blurRad="50800" dist="38100" dir="2700000" algn="tl" rotWithShape="0">
+              <a:prstClr val="black">
+                <a:alpha val="40000"/>
+              </a:prstClr>
+            </a:outerShdw>
+          </a:effectLst>
+        </p:spPr>
+        <p:txBody>
+          <a:bodyPr rtlCol="0" anchor="ctr"/>
+          <a:lstStyle/>
+          <a:p>
+            <a:pPr algn="ctr" defTabSz="914400">
+              <a:defRPr/>
+            </a:pPr>
+            <a:r>
+              <a:rPr lang="de-DE" sz="1050" kern="0">
+                <a:solidFill>
+                  <a:prstClr val="white"/>
+                </a:solidFill>
+                <a:latin typeface="Calibri" panose="020F0502020204030204"/>
+              </a:rPr>
+              <a:t>AirInterface #2</a:t>
+            </a:r>
+          </a:p>
+        </p:txBody>
+      </p:sp>
+      <p:cxnSp>
+        <p:nvCxnSpPr>
+          <p:cNvPr id="24" name="Gerader Verbinder 23">
+            <a:extLst>
+              <a:ext uri="{FF2B5EF4-FFF2-40B4-BE49-F238E27FC236}">
+                <a16:creationId xmlns:a16="http://schemas.microsoft.com/office/drawing/2014/main" id="{3D1EF9AE-C8C0-C87E-28E2-46BE1C9DDB11}"/>
+              </a:ext>
+            </a:extLst>
+          </p:cNvPr>
+          <p:cNvCxnSpPr>
+            <a:cxnSpLocks/>
+            <a:stCxn id="21" idx="1"/>
+            <a:endCxn id="22" idx="3"/>
+          </p:cNvCxnSpPr>
+          <p:nvPr/>
+        </p:nvCxnSpPr>
+        <p:spPr>
+          <a:xfrm flipH="1">
+            <a:off x="6423432" y="1766801"/>
+            <a:ext cx="791852" cy="0"/>
+          </a:xfrm>
+          <a:prstGeom prst="line">
+            <a:avLst/>
+          </a:prstGeom>
+          <a:ln>
+            <a:prstDash val="dash"/>
+          </a:ln>
+        </p:spPr>
+        <p:style>
+          <a:lnRef idx="2">
+            <a:schemeClr val="accent1"/>
+          </a:lnRef>
+          <a:fillRef idx="0">
+            <a:schemeClr val="accent1"/>
+          </a:fillRef>
+          <a:effectRef idx="1">
+            <a:schemeClr val="accent1"/>
+          </a:effectRef>
+          <a:fontRef idx="minor">
+            <a:schemeClr val="tx1"/>
+          </a:fontRef>
+        </p:style>
+      </p:cxnSp>
+      <p:cxnSp>
+        <p:nvCxnSpPr>
+          <p:cNvPr id="25" name="Gerader Verbinder 24">
+            <a:extLst>
+              <a:ext uri="{FF2B5EF4-FFF2-40B4-BE49-F238E27FC236}">
+                <a16:creationId xmlns:a16="http://schemas.microsoft.com/office/drawing/2014/main" id="{961DC7F2-4A58-3FE7-B7FA-47F176F07CFF}"/>
+              </a:ext>
+            </a:extLst>
+          </p:cNvPr>
+          <p:cNvCxnSpPr>
+            <a:cxnSpLocks/>
+            <a:stCxn id="21" idx="1"/>
+            <a:endCxn id="23" idx="3"/>
+          </p:cNvCxnSpPr>
+          <p:nvPr/>
+        </p:nvCxnSpPr>
+        <p:spPr>
+          <a:xfrm flipH="1">
+            <a:off x="6423432" y="1766801"/>
+            <a:ext cx="791852" cy="768626"/>
+          </a:xfrm>
+          <a:prstGeom prst="line">
+            <a:avLst/>
+          </a:prstGeom>
+          <a:ln>
+            <a:prstDash val="dash"/>
+          </a:ln>
+        </p:spPr>
+        <p:style>
+          <a:lnRef idx="2">
+            <a:schemeClr val="accent1"/>
+          </a:lnRef>
+          <a:fillRef idx="0">
+            <a:schemeClr val="accent1"/>
+          </a:fillRef>
+          <a:effectRef idx="1">
+            <a:schemeClr val="accent1"/>
+          </a:effectRef>
+          <a:fontRef idx="minor">
+            <a:schemeClr val="tx1"/>
+          </a:fontRef>
+        </p:style>
+      </p:cxnSp>
+      <p:cxnSp>
+        <p:nvCxnSpPr>
+          <p:cNvPr id="32" name="Gerader Verbinder 31">
+            <a:extLst>
+              <a:ext uri="{FF2B5EF4-FFF2-40B4-BE49-F238E27FC236}">
+                <a16:creationId xmlns:a16="http://schemas.microsoft.com/office/drawing/2014/main" id="{008127D1-09C5-341F-523E-3EE26B417D75}"/>
+              </a:ext>
+            </a:extLst>
+          </p:cNvPr>
+          <p:cNvCxnSpPr>
+            <a:stCxn id="5" idx="3"/>
+            <a:endCxn id="22" idx="1"/>
+          </p:cNvCxnSpPr>
+          <p:nvPr/>
+        </p:nvCxnSpPr>
+        <p:spPr>
+          <a:xfrm>
+            <a:off x="3527832" y="1766801"/>
+            <a:ext cx="1734147" cy="0"/>
+          </a:xfrm>
+          <a:prstGeom prst="line">
+            <a:avLst/>
+          </a:prstGeom>
+        </p:spPr>
+        <p:style>
+          <a:lnRef idx="2">
+            <a:schemeClr val="accent5"/>
+          </a:lnRef>
+          <a:fillRef idx="0">
+            <a:schemeClr val="accent5"/>
+          </a:fillRef>
+          <a:effectRef idx="1">
+            <a:schemeClr val="accent5"/>
+          </a:effectRef>
+          <a:fontRef idx="minor">
+            <a:schemeClr val="tx1"/>
+          </a:fontRef>
+        </p:style>
+      </p:cxnSp>
+      <p:cxnSp>
+        <p:nvCxnSpPr>
+          <p:cNvPr id="33" name="Gerader Verbinder 32">
+            <a:extLst>
+              <a:ext uri="{FF2B5EF4-FFF2-40B4-BE49-F238E27FC236}">
+                <a16:creationId xmlns:a16="http://schemas.microsoft.com/office/drawing/2014/main" id="{12384DB8-9AFF-BC4F-2EB8-85D4BA01BB22}"/>
+              </a:ext>
+            </a:extLst>
+          </p:cNvPr>
+          <p:cNvCxnSpPr>
+            <a:cxnSpLocks/>
+            <a:stCxn id="6" idx="3"/>
+            <a:endCxn id="23" idx="1"/>
+          </p:cNvCxnSpPr>
+          <p:nvPr/>
+        </p:nvCxnSpPr>
+        <p:spPr>
+          <a:xfrm>
+            <a:off x="3527832" y="2535427"/>
+            <a:ext cx="1734147" cy="0"/>
+          </a:xfrm>
+          <a:prstGeom prst="line">
+            <a:avLst/>
+          </a:prstGeom>
+        </p:spPr>
+        <p:style>
+          <a:lnRef idx="2">
+            <a:schemeClr val="accent6"/>
+          </a:lnRef>
+          <a:fillRef idx="0">
+            <a:schemeClr val="accent6"/>
+          </a:fillRef>
+          <a:effectRef idx="1">
+            <a:schemeClr val="accent6"/>
+          </a:effectRef>
+          <a:fontRef idx="minor">
+            <a:schemeClr val="tx1"/>
+          </a:fontRef>
+        </p:style>
+      </p:cxnSp>
+      <p:sp>
+        <p:nvSpPr>
+          <p:cNvPr id="37" name="Rechteck 36">
+            <a:extLst>
+              <a:ext uri="{FF2B5EF4-FFF2-40B4-BE49-F238E27FC236}">
+                <a16:creationId xmlns:a16="http://schemas.microsoft.com/office/drawing/2014/main" id="{388D120D-4A2F-B01C-C4C8-08A762172B49}"/>
+              </a:ext>
+            </a:extLst>
+          </p:cNvPr>
+          <p:cNvSpPr/>
+          <p:nvPr/>
+        </p:nvSpPr>
+        <p:spPr>
+          <a:xfrm>
+            <a:off x="4183282" y="1531105"/>
+            <a:ext cx="573690" cy="211283"/>
+          </a:xfrm>
+          <a:prstGeom prst="rect">
+            <a:avLst/>
+          </a:prstGeom>
+          <a:noFill/>
+          <a:ln w="12700" cap="flat" cmpd="sng" algn="ctr">
+            <a:noFill/>
+            <a:prstDash val="solid"/>
+            <a:miter lim="800000"/>
+          </a:ln>
+          <a:effectLst/>
+        </p:spPr>
+        <p:txBody>
+          <a:bodyPr lIns="36000" tIns="36000" rIns="36000" bIns="36000" rtlCol="0" anchor="t"/>
+          <a:lstStyle/>
+          <a:p>
+            <a:pPr defTabSz="914400"/>
+            <a:r>
+              <a:rPr lang="de-DE" sz="800" kern="0">
+                <a:solidFill>
+                  <a:prstClr val="black"/>
+                </a:solidFill>
+                <a:latin typeface="Calibri" panose="020F0502020204030204"/>
+              </a:rPr>
+              <a:t>305550001</a:t>
+            </a:r>
+          </a:p>
+        </p:txBody>
+      </p:sp>
+      <p:sp>
+        <p:nvSpPr>
+          <p:cNvPr id="38" name="Rechteck 37">
+            <a:extLst>
+              <a:ext uri="{FF2B5EF4-FFF2-40B4-BE49-F238E27FC236}">
+                <a16:creationId xmlns:a16="http://schemas.microsoft.com/office/drawing/2014/main" id="{512F6955-AA4A-84AE-140B-59FD36659D13}"/>
+              </a:ext>
+            </a:extLst>
+          </p:cNvPr>
+          <p:cNvSpPr/>
+          <p:nvPr/>
+        </p:nvSpPr>
+        <p:spPr>
+          <a:xfrm>
+            <a:off x="4183282" y="2326842"/>
+            <a:ext cx="573690" cy="211283"/>
+          </a:xfrm>
+          <a:prstGeom prst="rect">
+            <a:avLst/>
+          </a:prstGeom>
+          <a:noFill/>
+          <a:ln w="12700" cap="flat" cmpd="sng" algn="ctr">
+            <a:noFill/>
+            <a:prstDash val="solid"/>
+            <a:miter lim="800000"/>
+          </a:ln>
+          <a:effectLst/>
+        </p:spPr>
+        <p:txBody>
+          <a:bodyPr lIns="36000" tIns="36000" rIns="36000" bIns="36000" rtlCol="0" anchor="t"/>
+          <a:lstStyle/>
+          <a:p>
+            <a:pPr defTabSz="914400"/>
+            <a:r>
+              <a:rPr lang="de-DE" sz="800" kern="0">
+                <a:solidFill>
+                  <a:prstClr val="black"/>
+                </a:solidFill>
+                <a:latin typeface="Calibri" panose="020F0502020204030204"/>
+              </a:rPr>
+              <a:t>305550002</a:t>
+            </a:r>
+          </a:p>
+        </p:txBody>
+      </p:sp>
+      <p:sp>
+        <p:nvSpPr>
+          <p:cNvPr id="39" name="Textfeld 38">
+            <a:extLst>
+              <a:ext uri="{FF2B5EF4-FFF2-40B4-BE49-F238E27FC236}">
+                <a16:creationId xmlns:a16="http://schemas.microsoft.com/office/drawing/2014/main" id="{284D07A6-EA84-5FBE-1754-A3762D04FCA5}"/>
+              </a:ext>
+            </a:extLst>
+          </p:cNvPr>
+          <p:cNvSpPr txBox="1"/>
+          <p:nvPr/>
+        </p:nvSpPr>
+        <p:spPr>
+          <a:xfrm>
+            <a:off x="821635" y="3551810"/>
+            <a:ext cx="1361976" cy="369332"/>
+          </a:xfrm>
+          <a:prstGeom prst="rect">
+            <a:avLst/>
+          </a:prstGeom>
+          <a:noFill/>
+        </p:spPr>
+        <p:txBody>
+          <a:bodyPr wrap="none" rtlCol="0">
+            <a:spAutoFit/>
+          </a:bodyPr>
+          <a:lstStyle/>
+          <a:p>
+            <a:r>
+              <a:rPr lang="de-DE"/>
+              <a:t>Operational</a:t>
+            </a:r>
+          </a:p>
+        </p:txBody>
+      </p:sp>
+      <p:sp>
+        <p:nvSpPr>
+          <p:cNvPr id="40" name="Abgerundetes Rechteck 1">
+            <a:extLst>
+              <a:ext uri="{FF2B5EF4-FFF2-40B4-BE49-F238E27FC236}">
+                <a16:creationId xmlns:a16="http://schemas.microsoft.com/office/drawing/2014/main" id="{B0B13C56-89FA-AA8E-E079-1FD37F597A57}"/>
+              </a:ext>
+            </a:extLst>
+          </p:cNvPr>
+          <p:cNvSpPr/>
+          <p:nvPr/>
+        </p:nvSpPr>
+        <p:spPr>
+          <a:xfrm>
+            <a:off x="1052609" y="4287442"/>
+            <a:ext cx="537299" cy="445572"/>
+          </a:xfrm>
+          <a:prstGeom prst="roundRect">
+            <a:avLst/>
+          </a:prstGeom>
+          <a:solidFill>
+            <a:sysClr val="window" lastClr="FFFFFF">
+              <a:lumMod val="65000"/>
+            </a:sysClr>
+          </a:solidFill>
+          <a:ln w="12700" cap="flat" cmpd="sng" algn="ctr">
+            <a:solidFill>
+              <a:sysClr val="window" lastClr="FFFFFF">
+                <a:lumMod val="50000"/>
+              </a:sysClr>
+            </a:solidFill>
+            <a:prstDash val="solid"/>
+            <a:miter lim="800000"/>
+          </a:ln>
+          <a:effectLst>
+            <a:outerShdw blurRad="50800" dist="38100" dir="2700000" algn="tl" rotWithShape="0">
+              <a:prstClr val="black">
+                <a:alpha val="40000"/>
+              </a:prstClr>
+            </a:outerShdw>
+          </a:effectLst>
+        </p:spPr>
+        <p:txBody>
+          <a:bodyPr rtlCol="0" anchor="ctr"/>
+          <a:lstStyle/>
+          <a:p>
+            <a:pPr algn="ctr" defTabSz="914400">
+              <a:defRPr/>
+            </a:pPr>
+            <a:r>
+              <a:rPr lang="de-DE" sz="1050" kern="0" dirty="0">
+                <a:solidFill>
+                  <a:prstClr val="white"/>
+                </a:solidFill>
+                <a:latin typeface="Calibri" panose="020F0502020204030204"/>
+              </a:rPr>
+              <a:t>CC</a:t>
+            </a:r>
+          </a:p>
+        </p:txBody>
+      </p:sp>
+      <p:sp>
+        <p:nvSpPr>
+          <p:cNvPr id="41" name="Abgerundetes Rechteck 89">
+            <a:extLst>
+              <a:ext uri="{FF2B5EF4-FFF2-40B4-BE49-F238E27FC236}">
+                <a16:creationId xmlns:a16="http://schemas.microsoft.com/office/drawing/2014/main" id="{BCDD76B0-741C-42B5-AB68-5521380CADAF}"/>
+              </a:ext>
+            </a:extLst>
+          </p:cNvPr>
+          <p:cNvSpPr/>
+          <p:nvPr/>
+        </p:nvSpPr>
+        <p:spPr>
+          <a:xfrm>
+            <a:off x="2366379" y="4287442"/>
+            <a:ext cx="1161453" cy="445572"/>
+          </a:xfrm>
+          <a:prstGeom prst="roundRect">
+            <a:avLst/>
+          </a:prstGeom>
+          <a:solidFill>
+            <a:srgbClr val="4472C4">
+              <a:lumMod val="60000"/>
+              <a:lumOff val="40000"/>
+            </a:srgbClr>
+          </a:solidFill>
+          <a:ln w="12700" cap="flat" cmpd="sng" algn="ctr">
+            <a:solidFill>
+              <a:srgbClr val="4472C4">
+                <a:lumMod val="75000"/>
+              </a:srgbClr>
+            </a:solidFill>
+            <a:prstDash val="solid"/>
+            <a:miter lim="800000"/>
+          </a:ln>
+          <a:effectLst>
+            <a:outerShdw blurRad="50800" dist="38100" dir="2700000" algn="tl" rotWithShape="0">
+              <a:prstClr val="black">
+                <a:alpha val="40000"/>
+              </a:prstClr>
+            </a:outerShdw>
+          </a:effectLst>
+        </p:spPr>
+        <p:txBody>
+          <a:bodyPr rtlCol="0" anchor="ctr"/>
+          <a:lstStyle/>
+          <a:p>
+            <a:pPr algn="ctr" defTabSz="914400">
+              <a:defRPr/>
+            </a:pPr>
+            <a:r>
+              <a:rPr lang="de-DE" sz="1050" kern="0">
+                <a:solidFill>
+                  <a:prstClr val="white"/>
+                </a:solidFill>
+                <a:latin typeface="Calibri" panose="020F0502020204030204"/>
+              </a:rPr>
+              <a:t>AirInterface #1</a:t>
+            </a:r>
+          </a:p>
+        </p:txBody>
+      </p:sp>
+      <p:sp>
+        <p:nvSpPr>
+          <p:cNvPr id="42" name="Abgerundetes Rechteck 89">
+            <a:extLst>
+              <a:ext uri="{FF2B5EF4-FFF2-40B4-BE49-F238E27FC236}">
+                <a16:creationId xmlns:a16="http://schemas.microsoft.com/office/drawing/2014/main" id="{CD89B2EC-98C4-5751-7D75-90E6AADE6688}"/>
+              </a:ext>
+            </a:extLst>
+          </p:cNvPr>
+          <p:cNvSpPr/>
+          <p:nvPr/>
+        </p:nvSpPr>
+        <p:spPr>
+          <a:xfrm>
+            <a:off x="2366379" y="5056068"/>
+            <a:ext cx="1161453" cy="445572"/>
+          </a:xfrm>
+          <a:prstGeom prst="roundRect">
+            <a:avLst/>
+          </a:prstGeom>
+          <a:solidFill>
+            <a:srgbClr val="4472C4">
+              <a:lumMod val="60000"/>
+              <a:lumOff val="40000"/>
+            </a:srgbClr>
+          </a:solidFill>
+          <a:ln w="12700" cap="flat" cmpd="sng" algn="ctr">
+            <a:solidFill>
+              <a:srgbClr val="4472C4">
+                <a:lumMod val="75000"/>
+              </a:srgbClr>
+            </a:solidFill>
+            <a:prstDash val="solid"/>
+            <a:miter lim="800000"/>
+          </a:ln>
+          <a:effectLst>
+            <a:outerShdw blurRad="50800" dist="38100" dir="2700000" algn="tl" rotWithShape="0">
+              <a:prstClr val="black">
+                <a:alpha val="40000"/>
+              </a:prstClr>
+            </a:outerShdw>
+          </a:effectLst>
+        </p:spPr>
+        <p:txBody>
+          <a:bodyPr rtlCol="0" anchor="ctr"/>
+          <a:lstStyle/>
+          <a:p>
+            <a:pPr algn="ctr" defTabSz="914400">
+              <a:defRPr/>
+            </a:pPr>
+            <a:r>
+              <a:rPr lang="de-DE" sz="1050" kern="0">
+                <a:solidFill>
+                  <a:prstClr val="white"/>
+                </a:solidFill>
+                <a:latin typeface="Calibri" panose="020F0502020204030204"/>
+              </a:rPr>
+              <a:t>AirInterface #2</a:t>
+            </a:r>
+          </a:p>
+        </p:txBody>
+      </p:sp>
+      <p:cxnSp>
+        <p:nvCxnSpPr>
+          <p:cNvPr id="43" name="Gerader Verbinder 42">
+            <a:extLst>
+              <a:ext uri="{FF2B5EF4-FFF2-40B4-BE49-F238E27FC236}">
+                <a16:creationId xmlns:a16="http://schemas.microsoft.com/office/drawing/2014/main" id="{65F00F75-9332-4172-2DDB-6E0B344EC0B1}"/>
+              </a:ext>
+            </a:extLst>
+          </p:cNvPr>
+          <p:cNvCxnSpPr>
+            <a:stCxn id="40" idx="3"/>
+            <a:endCxn id="41" idx="1"/>
+          </p:cNvCxnSpPr>
+          <p:nvPr/>
+        </p:nvCxnSpPr>
+        <p:spPr>
+          <a:xfrm>
+            <a:off x="1589908" y="4510228"/>
+            <a:ext cx="776471" cy="0"/>
+          </a:xfrm>
+          <a:prstGeom prst="line">
+            <a:avLst/>
+          </a:prstGeom>
+          <a:ln>
+            <a:prstDash val="dash"/>
+          </a:ln>
+        </p:spPr>
+        <p:style>
+          <a:lnRef idx="2">
+            <a:schemeClr val="accent1"/>
+          </a:lnRef>
+          <a:fillRef idx="0">
+            <a:schemeClr val="accent1"/>
+          </a:fillRef>
+          <a:effectRef idx="1">
+            <a:schemeClr val="accent1"/>
+          </a:effectRef>
+          <a:fontRef idx="minor">
+            <a:schemeClr val="tx1"/>
+          </a:fontRef>
+        </p:style>
+      </p:cxnSp>
+      <p:cxnSp>
+        <p:nvCxnSpPr>
+          <p:cNvPr id="44" name="Gerader Verbinder 43">
+            <a:extLst>
+              <a:ext uri="{FF2B5EF4-FFF2-40B4-BE49-F238E27FC236}">
+                <a16:creationId xmlns:a16="http://schemas.microsoft.com/office/drawing/2014/main" id="{F522E477-B472-AFA5-96CB-25ECB63AF621}"/>
+              </a:ext>
+            </a:extLst>
+          </p:cNvPr>
+          <p:cNvCxnSpPr>
+            <a:cxnSpLocks/>
+            <a:stCxn id="40" idx="3"/>
+            <a:endCxn id="42" idx="1"/>
+          </p:cNvCxnSpPr>
+          <p:nvPr/>
+        </p:nvCxnSpPr>
+        <p:spPr>
+          <a:xfrm>
+            <a:off x="1589908" y="4510228"/>
+            <a:ext cx="776471" cy="768626"/>
+          </a:xfrm>
+          <a:prstGeom prst="line">
+            <a:avLst/>
+          </a:prstGeom>
+          <a:ln>
+            <a:prstDash val="dash"/>
+          </a:ln>
+        </p:spPr>
+        <p:style>
+          <a:lnRef idx="2">
+            <a:schemeClr val="accent1"/>
+          </a:lnRef>
+          <a:fillRef idx="0">
+            <a:schemeClr val="accent1"/>
+          </a:fillRef>
+          <a:effectRef idx="1">
+            <a:schemeClr val="accent1"/>
+          </a:effectRef>
+          <a:fontRef idx="minor">
+            <a:schemeClr val="tx1"/>
+          </a:fontRef>
+        </p:style>
+      </p:cxnSp>
+      <p:sp>
+        <p:nvSpPr>
+          <p:cNvPr id="45" name="Abgerundetes Rechteck 1">
+            <a:extLst>
+              <a:ext uri="{FF2B5EF4-FFF2-40B4-BE49-F238E27FC236}">
+                <a16:creationId xmlns:a16="http://schemas.microsoft.com/office/drawing/2014/main" id="{520B201F-A6CD-E1B9-7FE2-479A6B320884}"/>
+              </a:ext>
+            </a:extLst>
+          </p:cNvPr>
+          <p:cNvSpPr/>
+          <p:nvPr/>
+        </p:nvSpPr>
+        <p:spPr>
+          <a:xfrm>
+            <a:off x="7215284" y="4287442"/>
+            <a:ext cx="537299" cy="445572"/>
+          </a:xfrm>
+          <a:prstGeom prst="roundRect">
+            <a:avLst/>
+          </a:prstGeom>
+          <a:solidFill>
+            <a:sysClr val="window" lastClr="FFFFFF">
+              <a:lumMod val="65000"/>
+            </a:sysClr>
+          </a:solidFill>
+          <a:ln w="12700" cap="flat" cmpd="sng" algn="ctr">
+            <a:solidFill>
+              <a:sysClr val="window" lastClr="FFFFFF">
+                <a:lumMod val="50000"/>
+              </a:sysClr>
+            </a:solidFill>
+            <a:prstDash val="solid"/>
+            <a:miter lim="800000"/>
+          </a:ln>
+          <a:effectLst>
+            <a:outerShdw blurRad="50800" dist="38100" dir="2700000" algn="tl" rotWithShape="0">
+              <a:prstClr val="black">
+                <a:alpha val="40000"/>
+              </a:prstClr>
+            </a:outerShdw>
+          </a:effectLst>
+        </p:spPr>
+        <p:txBody>
+          <a:bodyPr rtlCol="0" anchor="ctr"/>
+          <a:lstStyle/>
+          <a:p>
+            <a:pPr algn="ctr" defTabSz="914400">
+              <a:defRPr/>
+            </a:pPr>
+            <a:r>
+              <a:rPr lang="de-DE" sz="1050" kern="0" dirty="0">
+                <a:solidFill>
+                  <a:prstClr val="white"/>
+                </a:solidFill>
+                <a:latin typeface="Calibri" panose="020F0502020204030204"/>
+              </a:rPr>
+              <a:t>CC</a:t>
+            </a:r>
+          </a:p>
+        </p:txBody>
+      </p:sp>
+      <p:sp>
+        <p:nvSpPr>
+          <p:cNvPr id="46" name="Abgerundetes Rechteck 89">
+            <a:extLst>
+              <a:ext uri="{FF2B5EF4-FFF2-40B4-BE49-F238E27FC236}">
+                <a16:creationId xmlns:a16="http://schemas.microsoft.com/office/drawing/2014/main" id="{D8EEDDD9-7BCA-0949-4D91-E71A66A0FBE0}"/>
+              </a:ext>
+            </a:extLst>
+          </p:cNvPr>
+          <p:cNvSpPr/>
+          <p:nvPr/>
+        </p:nvSpPr>
+        <p:spPr>
+          <a:xfrm>
+            <a:off x="5261979" y="4287442"/>
+            <a:ext cx="1161453" cy="445572"/>
+          </a:xfrm>
+          <a:prstGeom prst="roundRect">
+            <a:avLst/>
+          </a:prstGeom>
+          <a:solidFill>
+            <a:srgbClr val="4472C4">
+              <a:lumMod val="60000"/>
+              <a:lumOff val="40000"/>
+            </a:srgbClr>
+          </a:solidFill>
+          <a:ln w="12700" cap="flat" cmpd="sng" algn="ctr">
+            <a:solidFill>
+              <a:srgbClr val="4472C4">
+                <a:lumMod val="75000"/>
+              </a:srgbClr>
+            </a:solidFill>
+            <a:prstDash val="solid"/>
+            <a:miter lim="800000"/>
+          </a:ln>
+          <a:effectLst>
+            <a:outerShdw blurRad="50800" dist="38100" dir="2700000" algn="tl" rotWithShape="0">
+              <a:prstClr val="black">
+                <a:alpha val="40000"/>
+              </a:prstClr>
+            </a:outerShdw>
+          </a:effectLst>
+        </p:spPr>
+        <p:txBody>
+          <a:bodyPr rtlCol="0" anchor="ctr"/>
+          <a:lstStyle/>
+          <a:p>
+            <a:pPr algn="ctr" defTabSz="914400">
+              <a:defRPr/>
+            </a:pPr>
+            <a:r>
+              <a:rPr lang="de-DE" sz="1050" kern="0">
+                <a:solidFill>
+                  <a:prstClr val="white"/>
+                </a:solidFill>
+                <a:latin typeface="Calibri" panose="020F0502020204030204"/>
+              </a:rPr>
+              <a:t>AirInterface #1</a:t>
+            </a:r>
+          </a:p>
+        </p:txBody>
+      </p:sp>
+      <p:sp>
+        <p:nvSpPr>
+          <p:cNvPr id="47" name="Abgerundetes Rechteck 89">
+            <a:extLst>
+              <a:ext uri="{FF2B5EF4-FFF2-40B4-BE49-F238E27FC236}">
+                <a16:creationId xmlns:a16="http://schemas.microsoft.com/office/drawing/2014/main" id="{EE56F161-F939-C026-587D-C7E655A3ECB4}"/>
+              </a:ext>
+            </a:extLst>
+          </p:cNvPr>
+          <p:cNvSpPr/>
+          <p:nvPr/>
+        </p:nvSpPr>
+        <p:spPr>
+          <a:xfrm>
+            <a:off x="5261979" y="5056068"/>
+            <a:ext cx="1161453" cy="445572"/>
+          </a:xfrm>
+          <a:prstGeom prst="roundRect">
+            <a:avLst/>
+          </a:prstGeom>
+          <a:solidFill>
+            <a:srgbClr val="4472C4">
+              <a:lumMod val="60000"/>
+              <a:lumOff val="40000"/>
+            </a:srgbClr>
+          </a:solidFill>
+          <a:ln w="12700" cap="flat" cmpd="sng" algn="ctr">
+            <a:solidFill>
+              <a:srgbClr val="4472C4">
+                <a:lumMod val="75000"/>
+              </a:srgbClr>
+            </a:solidFill>
+            <a:prstDash val="solid"/>
+            <a:miter lim="800000"/>
+          </a:ln>
+          <a:effectLst>
+            <a:outerShdw blurRad="50800" dist="38100" dir="2700000" algn="tl" rotWithShape="0">
+              <a:prstClr val="black">
+                <a:alpha val="40000"/>
+              </a:prstClr>
+            </a:outerShdw>
+          </a:effectLst>
+        </p:spPr>
+        <p:txBody>
+          <a:bodyPr rtlCol="0" anchor="ctr"/>
+          <a:lstStyle/>
+          <a:p>
+            <a:pPr algn="ctr" defTabSz="914400">
+              <a:defRPr/>
+            </a:pPr>
+            <a:r>
+              <a:rPr lang="de-DE" sz="1050" kern="0">
+                <a:solidFill>
+                  <a:prstClr val="white"/>
+                </a:solidFill>
+                <a:latin typeface="Calibri" panose="020F0502020204030204"/>
+              </a:rPr>
+              <a:t>AirInterface #2</a:t>
+            </a:r>
+          </a:p>
+        </p:txBody>
+      </p:sp>
+      <p:cxnSp>
+        <p:nvCxnSpPr>
+          <p:cNvPr id="48" name="Gerader Verbinder 47">
+            <a:extLst>
+              <a:ext uri="{FF2B5EF4-FFF2-40B4-BE49-F238E27FC236}">
+                <a16:creationId xmlns:a16="http://schemas.microsoft.com/office/drawing/2014/main" id="{345CF39A-DBCC-FC7E-5648-B9014E0BDE58}"/>
+              </a:ext>
+            </a:extLst>
+          </p:cNvPr>
+          <p:cNvCxnSpPr>
+            <a:cxnSpLocks/>
+            <a:stCxn id="45" idx="1"/>
+            <a:endCxn id="46" idx="3"/>
+          </p:cNvCxnSpPr>
+          <p:nvPr/>
+        </p:nvCxnSpPr>
+        <p:spPr>
+          <a:xfrm flipH="1">
+            <a:off x="6423432" y="4510228"/>
+            <a:ext cx="791852" cy="0"/>
+          </a:xfrm>
+          <a:prstGeom prst="line">
+            <a:avLst/>
+          </a:prstGeom>
+          <a:ln>
+            <a:prstDash val="dash"/>
+          </a:ln>
+        </p:spPr>
+        <p:style>
+          <a:lnRef idx="2">
+            <a:schemeClr val="accent1"/>
+          </a:lnRef>
+          <a:fillRef idx="0">
+            <a:schemeClr val="accent1"/>
+          </a:fillRef>
+          <a:effectRef idx="1">
+            <a:schemeClr val="accent1"/>
+          </a:effectRef>
+          <a:fontRef idx="minor">
+            <a:schemeClr val="tx1"/>
+          </a:fontRef>
+        </p:style>
+      </p:cxnSp>
+      <p:cxnSp>
+        <p:nvCxnSpPr>
+          <p:cNvPr id="49" name="Gerader Verbinder 48">
+            <a:extLst>
+              <a:ext uri="{FF2B5EF4-FFF2-40B4-BE49-F238E27FC236}">
+                <a16:creationId xmlns:a16="http://schemas.microsoft.com/office/drawing/2014/main" id="{07AE9BCE-CFA2-3FA6-0928-265A117A3000}"/>
+              </a:ext>
+            </a:extLst>
+          </p:cNvPr>
+          <p:cNvCxnSpPr>
+            <a:cxnSpLocks/>
+            <a:stCxn id="45" idx="1"/>
+            <a:endCxn id="47" idx="3"/>
+          </p:cNvCxnSpPr>
+          <p:nvPr/>
+        </p:nvCxnSpPr>
+        <p:spPr>
+          <a:xfrm flipH="1">
+            <a:off x="6423432" y="4510228"/>
+            <a:ext cx="791852" cy="768626"/>
+          </a:xfrm>
+          <a:prstGeom prst="line">
+            <a:avLst/>
+          </a:prstGeom>
+          <a:ln>
+            <a:prstDash val="dash"/>
+          </a:ln>
+        </p:spPr>
+        <p:style>
+          <a:lnRef idx="2">
+            <a:schemeClr val="accent1"/>
+          </a:lnRef>
+          <a:fillRef idx="0">
+            <a:schemeClr val="accent1"/>
+          </a:fillRef>
+          <a:effectRef idx="1">
+            <a:schemeClr val="accent1"/>
+          </a:effectRef>
+          <a:fontRef idx="minor">
+            <a:schemeClr val="tx1"/>
+          </a:fontRef>
+        </p:style>
+      </p:cxnSp>
+      <p:cxnSp>
+        <p:nvCxnSpPr>
+          <p:cNvPr id="50" name="Gerader Verbinder 49">
+            <a:extLst>
+              <a:ext uri="{FF2B5EF4-FFF2-40B4-BE49-F238E27FC236}">
+                <a16:creationId xmlns:a16="http://schemas.microsoft.com/office/drawing/2014/main" id="{1486B58F-4900-8663-716A-24B8DECCED56}"/>
+              </a:ext>
+            </a:extLst>
+          </p:cNvPr>
+          <p:cNvCxnSpPr>
+            <a:stCxn id="41" idx="3"/>
+            <a:endCxn id="46" idx="1"/>
+          </p:cNvCxnSpPr>
+          <p:nvPr/>
+        </p:nvCxnSpPr>
+        <p:spPr>
+          <a:xfrm>
+            <a:off x="3527832" y="4510228"/>
+            <a:ext cx="1734147" cy="0"/>
+          </a:xfrm>
+          <a:prstGeom prst="line">
+            <a:avLst/>
+          </a:prstGeom>
+        </p:spPr>
+        <p:style>
+          <a:lnRef idx="2">
+            <a:schemeClr val="accent5"/>
+          </a:lnRef>
+          <a:fillRef idx="0">
+            <a:schemeClr val="accent5"/>
+          </a:fillRef>
+          <a:effectRef idx="1">
+            <a:schemeClr val="accent5"/>
+          </a:effectRef>
+          <a:fontRef idx="minor">
+            <a:schemeClr val="tx1"/>
+          </a:fontRef>
+        </p:style>
+      </p:cxnSp>
+      <p:cxnSp>
+        <p:nvCxnSpPr>
+          <p:cNvPr id="51" name="Gerader Verbinder 50">
+            <a:extLst>
+              <a:ext uri="{FF2B5EF4-FFF2-40B4-BE49-F238E27FC236}">
+                <a16:creationId xmlns:a16="http://schemas.microsoft.com/office/drawing/2014/main" id="{DC4F5D91-905B-8A82-30F0-6F28ACEED8AB}"/>
+              </a:ext>
+            </a:extLst>
+          </p:cNvPr>
+          <p:cNvCxnSpPr>
+            <a:cxnSpLocks/>
+            <a:stCxn id="42" idx="3"/>
+            <a:endCxn id="47" idx="1"/>
+          </p:cNvCxnSpPr>
+          <p:nvPr/>
+        </p:nvCxnSpPr>
+        <p:spPr>
+          <a:xfrm>
+            <a:off x="3527832" y="5278854"/>
+            <a:ext cx="1734147" cy="0"/>
+          </a:xfrm>
+          <a:prstGeom prst="line">
+            <a:avLst/>
+          </a:prstGeom>
+        </p:spPr>
+        <p:style>
+          <a:lnRef idx="2">
+            <a:schemeClr val="accent6"/>
+          </a:lnRef>
+          <a:fillRef idx="0">
+            <a:schemeClr val="accent6"/>
+          </a:fillRef>
+          <a:effectRef idx="1">
+            <a:schemeClr val="accent6"/>
+          </a:effectRef>
+          <a:fontRef idx="minor">
+            <a:schemeClr val="tx1"/>
+          </a:fontRef>
+        </p:style>
+      </p:cxnSp>
+      <p:cxnSp>
+        <p:nvCxnSpPr>
+          <p:cNvPr id="54" name="Gerader Verbinder 53">
+            <a:extLst>
+              <a:ext uri="{FF2B5EF4-FFF2-40B4-BE49-F238E27FC236}">
+                <a16:creationId xmlns:a16="http://schemas.microsoft.com/office/drawing/2014/main" id="{2AE42F98-2B38-D26A-8D2F-7D1F20273934}"/>
+              </a:ext>
+            </a:extLst>
+          </p:cNvPr>
+          <p:cNvCxnSpPr>
+            <a:cxnSpLocks/>
+            <a:stCxn id="41" idx="3"/>
+            <a:endCxn id="47" idx="1"/>
+          </p:cNvCxnSpPr>
+          <p:nvPr/>
+        </p:nvCxnSpPr>
+        <p:spPr>
+          <a:xfrm>
+            <a:off x="3527832" y="4510228"/>
+            <a:ext cx="1734147" cy="768626"/>
+          </a:xfrm>
+          <a:prstGeom prst="line">
+            <a:avLst/>
+          </a:prstGeom>
+        </p:spPr>
+        <p:style>
+          <a:lnRef idx="2">
+            <a:schemeClr val="accent5"/>
+          </a:lnRef>
+          <a:fillRef idx="0">
+            <a:schemeClr val="accent5"/>
+          </a:fillRef>
+          <a:effectRef idx="1">
+            <a:schemeClr val="accent5"/>
+          </a:effectRef>
+          <a:fontRef idx="minor">
+            <a:schemeClr val="tx1"/>
+          </a:fontRef>
+        </p:style>
+      </p:cxnSp>
+      <p:cxnSp>
+        <p:nvCxnSpPr>
+          <p:cNvPr id="57" name="Gerader Verbinder 56">
+            <a:extLst>
+              <a:ext uri="{FF2B5EF4-FFF2-40B4-BE49-F238E27FC236}">
+                <a16:creationId xmlns:a16="http://schemas.microsoft.com/office/drawing/2014/main" id="{AD779AC9-FD1D-260E-3F8E-E86C53F4FD02}"/>
+              </a:ext>
+            </a:extLst>
+          </p:cNvPr>
+          <p:cNvCxnSpPr>
+            <a:cxnSpLocks/>
+            <a:stCxn id="42" idx="3"/>
+            <a:endCxn id="46" idx="1"/>
+          </p:cNvCxnSpPr>
+          <p:nvPr/>
+        </p:nvCxnSpPr>
+        <p:spPr>
+          <a:xfrm flipV="1">
+            <a:off x="3527832" y="4510228"/>
+            <a:ext cx="1734147" cy="768626"/>
+          </a:xfrm>
+          <a:prstGeom prst="line">
+            <a:avLst/>
+          </a:prstGeom>
+        </p:spPr>
+        <p:style>
+          <a:lnRef idx="2">
+            <a:schemeClr val="accent5"/>
+          </a:lnRef>
+          <a:fillRef idx="0">
+            <a:schemeClr val="accent5"/>
+          </a:fillRef>
+          <a:effectRef idx="1">
+            <a:schemeClr val="accent5"/>
+          </a:effectRef>
+          <a:fontRef idx="minor">
+            <a:schemeClr val="tx1"/>
+          </a:fontRef>
+        </p:style>
+      </p:cxnSp>
+      <p:cxnSp>
+        <p:nvCxnSpPr>
+          <p:cNvPr id="60" name="Gerader Verbinder 59">
+            <a:extLst>
+              <a:ext uri="{FF2B5EF4-FFF2-40B4-BE49-F238E27FC236}">
+                <a16:creationId xmlns:a16="http://schemas.microsoft.com/office/drawing/2014/main" id="{A033104E-4A3B-522F-2238-2C63530AEB74}"/>
+              </a:ext>
+            </a:extLst>
+          </p:cNvPr>
+          <p:cNvCxnSpPr>
+            <a:cxnSpLocks/>
+            <a:stCxn id="42" idx="3"/>
+          </p:cNvCxnSpPr>
+          <p:nvPr/>
+        </p:nvCxnSpPr>
+        <p:spPr>
+          <a:xfrm flipV="1">
+            <a:off x="3527832" y="4628721"/>
+            <a:ext cx="1734147" cy="650133"/>
+          </a:xfrm>
+          <a:prstGeom prst="line">
+            <a:avLst/>
+          </a:prstGeom>
+        </p:spPr>
+        <p:style>
+          <a:lnRef idx="2">
+            <a:schemeClr val="accent6"/>
+          </a:lnRef>
+          <a:fillRef idx="0">
+            <a:schemeClr val="accent6"/>
+          </a:fillRef>
+          <a:effectRef idx="1">
+            <a:schemeClr val="accent6"/>
+          </a:effectRef>
+          <a:fontRef idx="minor">
+            <a:schemeClr val="tx1"/>
+          </a:fontRef>
+        </p:style>
+      </p:cxnSp>
+      <p:cxnSp>
+        <p:nvCxnSpPr>
+          <p:cNvPr id="62" name="Gerader Verbinder 61">
+            <a:extLst>
+              <a:ext uri="{FF2B5EF4-FFF2-40B4-BE49-F238E27FC236}">
+                <a16:creationId xmlns:a16="http://schemas.microsoft.com/office/drawing/2014/main" id="{BF032092-E26D-1B90-BD2E-72B3E4C7AD94}"/>
+              </a:ext>
+            </a:extLst>
+          </p:cNvPr>
+          <p:cNvCxnSpPr>
+            <a:cxnSpLocks/>
+            <a:stCxn id="41" idx="3"/>
+          </p:cNvCxnSpPr>
+          <p:nvPr/>
+        </p:nvCxnSpPr>
+        <p:spPr>
+          <a:xfrm>
+            <a:off x="3527832" y="4510228"/>
+            <a:ext cx="1734147" cy="639421"/>
+          </a:xfrm>
+          <a:prstGeom prst="line">
+            <a:avLst/>
+          </a:prstGeom>
+        </p:spPr>
+        <p:style>
+          <a:lnRef idx="2">
+            <a:schemeClr val="accent6"/>
+          </a:lnRef>
+          <a:fillRef idx="0">
+            <a:schemeClr val="accent6"/>
+          </a:fillRef>
+          <a:effectRef idx="1">
+            <a:schemeClr val="accent6"/>
+          </a:effectRef>
+          <a:fontRef idx="minor">
+            <a:schemeClr val="tx1"/>
+          </a:fontRef>
+        </p:style>
+      </p:cxnSp>
+      <p:cxnSp>
+        <p:nvCxnSpPr>
+          <p:cNvPr id="71" name="Gerader Verbinder 70">
+            <a:extLst>
+              <a:ext uri="{FF2B5EF4-FFF2-40B4-BE49-F238E27FC236}">
+                <a16:creationId xmlns:a16="http://schemas.microsoft.com/office/drawing/2014/main" id="{73E7F552-6247-942F-149B-B2F4BE1088D8}"/>
+              </a:ext>
+            </a:extLst>
+          </p:cNvPr>
+          <p:cNvCxnSpPr/>
+          <p:nvPr/>
+        </p:nvCxnSpPr>
+        <p:spPr>
+          <a:xfrm>
+            <a:off x="3527832" y="5386528"/>
+            <a:ext cx="1734147" cy="0"/>
+          </a:xfrm>
+          <a:prstGeom prst="line">
+            <a:avLst/>
+          </a:prstGeom>
+        </p:spPr>
+        <p:style>
+          <a:lnRef idx="2">
+            <a:schemeClr val="accent5"/>
+          </a:lnRef>
+          <a:fillRef idx="0">
+            <a:schemeClr val="accent5"/>
+          </a:fillRef>
+          <a:effectRef idx="1">
+            <a:schemeClr val="accent5"/>
+          </a:effectRef>
+          <a:fontRef idx="minor">
+            <a:schemeClr val="tx1"/>
+          </a:fontRef>
+        </p:style>
+      </p:cxnSp>
+      <p:cxnSp>
+        <p:nvCxnSpPr>
+          <p:cNvPr id="72" name="Gerader Verbinder 71">
+            <a:extLst>
+              <a:ext uri="{FF2B5EF4-FFF2-40B4-BE49-F238E27FC236}">
+                <a16:creationId xmlns:a16="http://schemas.microsoft.com/office/drawing/2014/main" id="{C9A4C412-BCBB-33AC-984B-B1834B53C4BF}"/>
+              </a:ext>
+            </a:extLst>
+          </p:cNvPr>
+          <p:cNvCxnSpPr>
+            <a:cxnSpLocks/>
+          </p:cNvCxnSpPr>
+          <p:nvPr/>
+        </p:nvCxnSpPr>
+        <p:spPr>
+          <a:xfrm>
+            <a:off x="3527832" y="4420050"/>
+            <a:ext cx="1734147" cy="0"/>
+          </a:xfrm>
+          <a:prstGeom prst="line">
+            <a:avLst/>
+          </a:prstGeom>
+        </p:spPr>
+        <p:style>
+          <a:lnRef idx="2">
+            <a:schemeClr val="accent6"/>
+          </a:lnRef>
+          <a:fillRef idx="0">
+            <a:schemeClr val="accent6"/>
+          </a:fillRef>
+          <a:effectRef idx="1">
+            <a:schemeClr val="accent6"/>
+          </a:effectRef>
+          <a:fontRef idx="minor">
+            <a:schemeClr val="tx1"/>
+          </a:fontRef>
+        </p:style>
+      </p:cxnSp>
+      <p:sp>
+        <p:nvSpPr>
+          <p:cNvPr id="73" name="Rechteck 72">
+            <a:extLst>
+              <a:ext uri="{FF2B5EF4-FFF2-40B4-BE49-F238E27FC236}">
+                <a16:creationId xmlns:a16="http://schemas.microsoft.com/office/drawing/2014/main" id="{FC89CEB9-D499-084D-0F30-40B9451B7F13}"/>
+              </a:ext>
+            </a:extLst>
+          </p:cNvPr>
+          <p:cNvSpPr/>
+          <p:nvPr/>
+        </p:nvSpPr>
+        <p:spPr>
+          <a:xfrm>
+            <a:off x="4379355" y="4199486"/>
+            <a:ext cx="573690" cy="211283"/>
+          </a:xfrm>
+          <a:prstGeom prst="rect">
+            <a:avLst/>
+          </a:prstGeom>
+          <a:noFill/>
+          <a:ln w="12700" cap="flat" cmpd="sng" algn="ctr">
+            <a:noFill/>
+            <a:prstDash val="solid"/>
+            <a:miter lim="800000"/>
+          </a:ln>
+          <a:effectLst/>
+        </p:spPr>
+        <p:txBody>
+          <a:bodyPr lIns="36000" tIns="36000" rIns="36000" bIns="36000" rtlCol="0" anchor="t"/>
+          <a:lstStyle/>
+          <a:p>
+            <a:pPr defTabSz="914400"/>
+            <a:r>
+              <a:rPr lang="de-DE" sz="800" kern="0">
+                <a:solidFill>
+                  <a:prstClr val="black"/>
+                </a:solidFill>
+                <a:latin typeface="Calibri" panose="020F0502020204030204"/>
+              </a:rPr>
+              <a:t>?</a:t>
+            </a:r>
+          </a:p>
+        </p:txBody>
+      </p:sp>
+      <p:sp>
+        <p:nvSpPr>
+          <p:cNvPr id="74" name="Rechteck 73">
+            <a:extLst>
+              <a:ext uri="{FF2B5EF4-FFF2-40B4-BE49-F238E27FC236}">
+                <a16:creationId xmlns:a16="http://schemas.microsoft.com/office/drawing/2014/main" id="{60BA63CA-CDAA-B55B-0A46-C06E0BFF959B}"/>
+              </a:ext>
+            </a:extLst>
+          </p:cNvPr>
+          <p:cNvSpPr/>
+          <p:nvPr/>
+        </p:nvSpPr>
+        <p:spPr>
+          <a:xfrm>
+            <a:off x="4379355" y="4663821"/>
+            <a:ext cx="573690" cy="211283"/>
+          </a:xfrm>
+          <a:prstGeom prst="rect">
+            <a:avLst/>
+          </a:prstGeom>
+          <a:noFill/>
+          <a:ln w="12700" cap="flat" cmpd="sng" algn="ctr">
+            <a:noFill/>
+            <a:prstDash val="solid"/>
+            <a:miter lim="800000"/>
+          </a:ln>
+          <a:effectLst/>
+        </p:spPr>
+        <p:txBody>
+          <a:bodyPr lIns="36000" tIns="36000" rIns="36000" bIns="36000" rtlCol="0" anchor="t"/>
+          <a:lstStyle/>
+          <a:p>
+            <a:pPr defTabSz="914400"/>
+            <a:r>
+              <a:rPr lang="de-DE" sz="800" kern="0">
+                <a:solidFill>
+                  <a:prstClr val="black"/>
+                </a:solidFill>
+                <a:latin typeface="Calibri" panose="020F0502020204030204"/>
+              </a:rPr>
+              <a:t>?</a:t>
+            </a:r>
+          </a:p>
+        </p:txBody>
+      </p:sp>
+      <p:sp>
+        <p:nvSpPr>
+          <p:cNvPr id="75" name="Rechteck 74">
+            <a:extLst>
+              <a:ext uri="{FF2B5EF4-FFF2-40B4-BE49-F238E27FC236}">
+                <a16:creationId xmlns:a16="http://schemas.microsoft.com/office/drawing/2014/main" id="{4637379A-8802-3B1A-9D98-C4146D84E565}"/>
+              </a:ext>
+            </a:extLst>
+          </p:cNvPr>
+          <p:cNvSpPr/>
+          <p:nvPr/>
+        </p:nvSpPr>
+        <p:spPr>
+          <a:xfrm>
+            <a:off x="4354488" y="5098772"/>
+            <a:ext cx="573690" cy="211283"/>
+          </a:xfrm>
+          <a:prstGeom prst="rect">
+            <a:avLst/>
+          </a:prstGeom>
+          <a:noFill/>
+          <a:ln w="12700" cap="flat" cmpd="sng" algn="ctr">
+            <a:noFill/>
+            <a:prstDash val="solid"/>
+            <a:miter lim="800000"/>
+          </a:ln>
+          <a:effectLst/>
+        </p:spPr>
+        <p:txBody>
+          <a:bodyPr lIns="36000" tIns="36000" rIns="36000" bIns="36000" rtlCol="0" anchor="t"/>
+          <a:lstStyle/>
+          <a:p>
+            <a:pPr defTabSz="914400"/>
+            <a:r>
+              <a:rPr lang="de-DE" sz="800" kern="0">
+                <a:solidFill>
+                  <a:prstClr val="black"/>
+                </a:solidFill>
+                <a:latin typeface="Calibri" panose="020F0502020204030204"/>
+              </a:rPr>
+              <a:t>?</a:t>
+            </a:r>
+          </a:p>
+        </p:txBody>
+      </p:sp>
+    </p:spTree>
+    <p:extLst>
+      <p:ext uri="{BB962C8B-B14F-4D97-AF65-F5344CB8AC3E}">
+        <p14:creationId xmlns:p14="http://schemas.microsoft.com/office/powerpoint/2010/main" val="949934280"/>
       </p:ext>
     </p:extLst>
   </p:cSld>

</xml_diff>

<commit_message>
Update list of Functions
</commit_message>
<xml_diff>
--- a/spec/Diagrams/InformationStructure/InformationStructure.pptx
+++ b/spec/Diagrams/InformationStructure/InformationStructure.pptx
@@ -5,13 +5,14 @@
     <p:sldMasterId id="2147483732" r:id="rId1"/>
   </p:sldMasterIdLst>
   <p:notesMasterIdLst>
-    <p:notesMasterId r:id="rId6"/>
+    <p:notesMasterId r:id="rId7"/>
   </p:notesMasterIdLst>
   <p:sldIdLst>
     <p:sldId id="305" r:id="rId2"/>
     <p:sldId id="302" r:id="rId3"/>
     <p:sldId id="303" r:id="rId4"/>
     <p:sldId id="304" r:id="rId5"/>
+    <p:sldId id="306" r:id="rId6"/>
   </p:sldIdLst>
   <p:sldSz cx="23399750" cy="18000663"/>
   <p:notesSz cx="6858000" cy="9144000"/>
@@ -200,7 +201,7 @@
           <a:p>
             <a:fld id="{37CCF725-7468-4D3D-9E24-A16745BBBA77}" type="datetimeFigureOut">
               <a:rPr lang="de-DE" smtClean="0"/>
-              <a:t>30.04.2025</a:t>
+              <a:t>02.05.2025</a:t>
             </a:fld>
             <a:endParaRPr lang="de-DE"/>
           </a:p>
@@ -598,7 +599,7 @@
           <a:p>
             <a:fld id="{9A2764DB-E7DF-4EA7-A1AF-05A77C280FCA}" type="datetimeFigureOut">
               <a:rPr lang="de-DE" smtClean="0"/>
-              <a:t>30.04.2025</a:t>
+              <a:t>02.05.2025</a:t>
             </a:fld>
             <a:endParaRPr lang="de-DE"/>
           </a:p>
@@ -768,7 +769,7 @@
           <a:p>
             <a:fld id="{9A2764DB-E7DF-4EA7-A1AF-05A77C280FCA}" type="datetimeFigureOut">
               <a:rPr lang="de-DE" smtClean="0"/>
-              <a:t>30.04.2025</a:t>
+              <a:t>02.05.2025</a:t>
             </a:fld>
             <a:endParaRPr lang="de-DE"/>
           </a:p>
@@ -948,7 +949,7 @@
           <a:p>
             <a:fld id="{9A2764DB-E7DF-4EA7-A1AF-05A77C280FCA}" type="datetimeFigureOut">
               <a:rPr lang="de-DE" smtClean="0"/>
-              <a:t>30.04.2025</a:t>
+              <a:t>02.05.2025</a:t>
             </a:fld>
             <a:endParaRPr lang="de-DE"/>
           </a:p>
@@ -1118,7 +1119,7 @@
           <a:p>
             <a:fld id="{9A2764DB-E7DF-4EA7-A1AF-05A77C280FCA}" type="datetimeFigureOut">
               <a:rPr lang="de-DE" smtClean="0"/>
-              <a:t>30.04.2025</a:t>
+              <a:t>02.05.2025</a:t>
             </a:fld>
             <a:endParaRPr lang="de-DE"/>
           </a:p>
@@ -1364,7 +1365,7 @@
           <a:p>
             <a:fld id="{9A2764DB-E7DF-4EA7-A1AF-05A77C280FCA}" type="datetimeFigureOut">
               <a:rPr lang="de-DE" smtClean="0"/>
-              <a:t>30.04.2025</a:t>
+              <a:t>02.05.2025</a:t>
             </a:fld>
             <a:endParaRPr lang="de-DE"/>
           </a:p>
@@ -1596,7 +1597,7 @@
           <a:p>
             <a:fld id="{9A2764DB-E7DF-4EA7-A1AF-05A77C280FCA}" type="datetimeFigureOut">
               <a:rPr lang="de-DE" smtClean="0"/>
-              <a:t>30.04.2025</a:t>
+              <a:t>02.05.2025</a:t>
             </a:fld>
             <a:endParaRPr lang="de-DE"/>
           </a:p>
@@ -1963,7 +1964,7 @@
           <a:p>
             <a:fld id="{9A2764DB-E7DF-4EA7-A1AF-05A77C280FCA}" type="datetimeFigureOut">
               <a:rPr lang="de-DE" smtClean="0"/>
-              <a:t>30.04.2025</a:t>
+              <a:t>02.05.2025</a:t>
             </a:fld>
             <a:endParaRPr lang="de-DE"/>
           </a:p>
@@ -2081,7 +2082,7 @@
           <a:p>
             <a:fld id="{9A2764DB-E7DF-4EA7-A1AF-05A77C280FCA}" type="datetimeFigureOut">
               <a:rPr lang="de-DE" smtClean="0"/>
-              <a:t>30.04.2025</a:t>
+              <a:t>02.05.2025</a:t>
             </a:fld>
             <a:endParaRPr lang="de-DE"/>
           </a:p>
@@ -2176,7 +2177,7 @@
           <a:p>
             <a:fld id="{9A2764DB-E7DF-4EA7-A1AF-05A77C280FCA}" type="datetimeFigureOut">
               <a:rPr lang="de-DE" smtClean="0"/>
-              <a:t>30.04.2025</a:t>
+              <a:t>02.05.2025</a:t>
             </a:fld>
             <a:endParaRPr lang="de-DE"/>
           </a:p>
@@ -2453,7 +2454,7 @@
           <a:p>
             <a:fld id="{9A2764DB-E7DF-4EA7-A1AF-05A77C280FCA}" type="datetimeFigureOut">
               <a:rPr lang="de-DE" smtClean="0"/>
-              <a:t>30.04.2025</a:t>
+              <a:t>02.05.2025</a:t>
             </a:fld>
             <a:endParaRPr lang="de-DE"/>
           </a:p>
@@ -2710,7 +2711,7 @@
           <a:p>
             <a:fld id="{9A2764DB-E7DF-4EA7-A1AF-05A77C280FCA}" type="datetimeFigureOut">
               <a:rPr lang="de-DE" smtClean="0"/>
-              <a:t>30.04.2025</a:t>
+              <a:t>02.05.2025</a:t>
             </a:fld>
             <a:endParaRPr lang="de-DE"/>
           </a:p>
@@ -2923,7 +2924,7 @@
           <a:p>
             <a:fld id="{9A2764DB-E7DF-4EA7-A1AF-05A77C280FCA}" type="datetimeFigureOut">
               <a:rPr lang="de-DE" smtClean="0"/>
-              <a:t>30.04.2025</a:t>
+              <a:t>02.05.2025</a:t>
             </a:fld>
             <a:endParaRPr lang="de-DE"/>
           </a:p>
@@ -3342,7 +3343,7 @@
         </p:nvSpPr>
         <p:spPr>
           <a:xfrm>
-            <a:off x="5924550" y="134232"/>
+            <a:off x="1131324" y="960141"/>
             <a:ext cx="11063135" cy="7457194"/>
           </a:xfrm>
           <a:prstGeom prst="rect">
@@ -3403,7 +3404,7 @@
         </p:nvSpPr>
         <p:spPr>
           <a:xfrm>
-            <a:off x="6143624" y="2341094"/>
+            <a:off x="1350398" y="3167003"/>
             <a:ext cx="10580285" cy="5011539"/>
           </a:xfrm>
           <a:prstGeom prst="rect">
@@ -3464,7 +3465,7 @@
         </p:nvSpPr>
         <p:spPr>
           <a:xfrm>
-            <a:off x="10725613" y="3845387"/>
+            <a:off x="5932387" y="4671296"/>
             <a:ext cx="5725002" cy="3283971"/>
           </a:xfrm>
           <a:prstGeom prst="rect">
@@ -3526,7 +3527,7 @@
         </p:nvSpPr>
         <p:spPr>
           <a:xfrm>
-            <a:off x="11342439" y="4114937"/>
+            <a:off x="6549213" y="4940846"/>
             <a:ext cx="537299" cy="445572"/>
           </a:xfrm>
           <a:prstGeom prst="roundRect">
@@ -3591,7 +3592,7 @@
         </p:nvCxnSpPr>
         <p:spPr>
           <a:xfrm>
-            <a:off x="11611089" y="4560509"/>
+            <a:off x="6817863" y="5386418"/>
             <a:ext cx="0" cy="837717"/>
           </a:xfrm>
           <a:prstGeom prst="straightConnector1">
@@ -3623,7 +3624,7 @@
         </p:nvSpPr>
         <p:spPr>
           <a:xfrm>
-            <a:off x="12847035" y="4132860"/>
+            <a:off x="8053809" y="4958769"/>
             <a:ext cx="2377663" cy="314831"/>
           </a:xfrm>
           <a:prstGeom prst="rect">
@@ -3694,7 +3695,7 @@
         </p:nvCxnSpPr>
         <p:spPr>
           <a:xfrm flipV="1">
-            <a:off x="11879738" y="4290276"/>
+            <a:off x="7086512" y="5116185"/>
             <a:ext cx="967297" cy="47447"/>
           </a:xfrm>
           <a:prstGeom prst="straightConnector1">
@@ -3726,7 +3727,7 @@
         </p:nvSpPr>
         <p:spPr>
           <a:xfrm>
-            <a:off x="6352215" y="3850254"/>
+            <a:off x="1558989" y="4676163"/>
             <a:ext cx="4363197" cy="3283971"/>
           </a:xfrm>
           <a:prstGeom prst="rect">
@@ -3787,7 +3788,7 @@
         </p:nvSpPr>
         <p:spPr>
           <a:xfrm>
-            <a:off x="9236356" y="4290276"/>
+            <a:off x="4443130" y="5116185"/>
             <a:ext cx="537299" cy="445572"/>
           </a:xfrm>
           <a:prstGeom prst="roundRect">
@@ -3854,7 +3855,7 @@
         </p:nvSpPr>
         <p:spPr>
           <a:xfrm>
-            <a:off x="6601216" y="4274533"/>
+            <a:off x="1807990" y="5100442"/>
             <a:ext cx="1756328" cy="527420"/>
           </a:xfrm>
           <a:prstGeom prst="rect">
@@ -3940,7 +3941,7 @@
         </p:nvCxnSpPr>
         <p:spPr>
           <a:xfrm flipH="1">
-            <a:off x="8357544" y="4513062"/>
+            <a:off x="3564318" y="5338971"/>
             <a:ext cx="878812" cy="25181"/>
           </a:xfrm>
           <a:prstGeom prst="straightConnector1">
@@ -3976,7 +3977,7 @@
         </p:nvCxnSpPr>
         <p:spPr>
           <a:xfrm>
-            <a:off x="9505006" y="4735848"/>
+            <a:off x="4711780" y="5561757"/>
             <a:ext cx="1837433" cy="885164"/>
           </a:xfrm>
           <a:prstGeom prst="straightConnector1">
@@ -4008,7 +4009,7 @@
         </p:nvSpPr>
         <p:spPr>
           <a:xfrm>
-            <a:off x="11342440" y="2555173"/>
+            <a:off x="6549214" y="3381082"/>
             <a:ext cx="537299" cy="445572"/>
           </a:xfrm>
           <a:prstGeom prst="roundRect">
@@ -4075,7 +4076,7 @@
         </p:nvSpPr>
         <p:spPr>
           <a:xfrm>
-            <a:off x="12847035" y="2596282"/>
+            <a:off x="8053809" y="3422191"/>
             <a:ext cx="1685583" cy="336074"/>
           </a:xfrm>
           <a:prstGeom prst="rect">
@@ -4128,7 +4129,7 @@
         </p:nvCxnSpPr>
         <p:spPr>
           <a:xfrm flipV="1">
-            <a:off x="11879739" y="2764319"/>
+            <a:off x="7086513" y="3590228"/>
             <a:ext cx="967296" cy="13640"/>
           </a:xfrm>
           <a:prstGeom prst="straightConnector1">
@@ -4160,7 +4161,7 @@
         </p:nvSpPr>
         <p:spPr>
           <a:xfrm>
-            <a:off x="12847034" y="4621572"/>
+            <a:off x="8053808" y="5447481"/>
             <a:ext cx="2377664" cy="2092191"/>
           </a:xfrm>
           <a:prstGeom prst="rect">
@@ -4380,7 +4381,7 @@
         </p:nvSpPr>
         <p:spPr>
           <a:xfrm>
-            <a:off x="11342439" y="5398226"/>
+            <a:off x="6549213" y="6224135"/>
             <a:ext cx="537299" cy="445572"/>
           </a:xfrm>
           <a:prstGeom prst="roundRect">
@@ -4445,7 +4446,7 @@
         </p:nvCxnSpPr>
         <p:spPr>
           <a:xfrm>
-            <a:off x="11879738" y="5621012"/>
+            <a:off x="7086512" y="6446921"/>
             <a:ext cx="967296" cy="46656"/>
           </a:xfrm>
           <a:prstGeom prst="straightConnector1">
@@ -4477,7 +4478,7 @@
         </p:nvSpPr>
         <p:spPr>
           <a:xfrm>
-            <a:off x="11342439" y="316695"/>
+            <a:off x="6549213" y="1142604"/>
             <a:ext cx="537299" cy="445572"/>
           </a:xfrm>
           <a:prstGeom prst="roundRect">
@@ -4548,7 +4549,7 @@
         </p:nvCxnSpPr>
         <p:spPr>
           <a:xfrm>
-            <a:off x="11611089" y="762267"/>
+            <a:off x="6817863" y="1588176"/>
             <a:ext cx="1" cy="1792906"/>
           </a:xfrm>
           <a:prstGeom prst="straightConnector1">
@@ -4580,7 +4581,7 @@
         </p:nvSpPr>
         <p:spPr>
           <a:xfrm>
-            <a:off x="12491734" y="316954"/>
+            <a:off x="7698508" y="1142863"/>
             <a:ext cx="537299" cy="445572"/>
           </a:xfrm>
           <a:prstGeom prst="roundRect">
@@ -4647,7 +4648,7 @@
         </p:nvSpPr>
         <p:spPr>
           <a:xfrm>
-            <a:off x="12490301" y="1132869"/>
+            <a:off x="7697075" y="1958778"/>
             <a:ext cx="537299" cy="445572"/>
           </a:xfrm>
           <a:prstGeom prst="roundRect">
@@ -4718,7 +4719,7 @@
         </p:nvCxnSpPr>
         <p:spPr>
           <a:xfrm>
-            <a:off x="11879738" y="539481"/>
+            <a:off x="7086512" y="1365390"/>
             <a:ext cx="611996" cy="259"/>
           </a:xfrm>
           <a:prstGeom prst="straightConnector1">
@@ -4754,7 +4755,7 @@
         </p:nvCxnSpPr>
         <p:spPr>
           <a:xfrm flipH="1">
-            <a:off x="12758951" y="762526"/>
+            <a:off x="7965725" y="1588435"/>
             <a:ext cx="1433" cy="370343"/>
           </a:xfrm>
           <a:prstGeom prst="straightConnector1">
@@ -4786,7 +4787,7 @@
         </p:nvSpPr>
         <p:spPr>
           <a:xfrm>
-            <a:off x="10188314" y="317362"/>
+            <a:off x="5395088" y="1143271"/>
             <a:ext cx="537299" cy="445572"/>
           </a:xfrm>
           <a:prstGeom prst="roundRect">
@@ -4853,7 +4854,7 @@
         </p:nvSpPr>
         <p:spPr>
           <a:xfrm>
-            <a:off x="8754064" y="358769"/>
+            <a:off x="3960838" y="1184678"/>
             <a:ext cx="722507" cy="424727"/>
           </a:xfrm>
           <a:prstGeom prst="rect">
@@ -4930,7 +4931,7 @@
         </p:nvCxnSpPr>
         <p:spPr>
           <a:xfrm flipH="1">
-            <a:off x="9476571" y="540148"/>
+            <a:off x="4683345" y="1366057"/>
             <a:ext cx="711743" cy="30985"/>
           </a:xfrm>
           <a:prstGeom prst="straightConnector1">
@@ -4966,7 +4967,7 @@
         </p:nvCxnSpPr>
         <p:spPr>
           <a:xfrm flipH="1">
-            <a:off x="10725613" y="539481"/>
+            <a:off x="5932387" y="1365390"/>
             <a:ext cx="616826" cy="667"/>
           </a:xfrm>
           <a:prstGeom prst="straightConnector1">
@@ -5056,7 +5057,7 @@
         </p:nvSpPr>
         <p:spPr>
           <a:xfrm>
-            <a:off x="13954958" y="750221"/>
+            <a:off x="9161732" y="1576130"/>
             <a:ext cx="1905036" cy="1056537"/>
           </a:xfrm>
           <a:prstGeom prst="rect">
@@ -5086,7 +5087,7 @@
                 </a:solidFill>
                 <a:latin typeface="Calibri" panose="020F0502020204030204"/>
               </a:rPr>
-              <a:t>local-id=[LinkId]</a:t>
+              <a:t>_affected-link=[LinkId]</a:t>
             </a:r>
           </a:p>
           <a:p>
@@ -5187,7 +5188,7 @@
         </p:nvCxnSpPr>
         <p:spPr>
           <a:xfrm flipV="1">
-            <a:off x="13027600" y="1278490"/>
+            <a:off x="8234374" y="2104399"/>
             <a:ext cx="927358" cy="77165"/>
           </a:xfrm>
           <a:prstGeom prst="straightConnector1">
@@ -5223,7 +5224,7 @@
         </p:nvCxnSpPr>
         <p:spPr>
           <a:xfrm flipH="1">
-            <a:off x="11611089" y="3000745"/>
+            <a:off x="6817863" y="3826654"/>
             <a:ext cx="1" cy="1114192"/>
           </a:xfrm>
           <a:prstGeom prst="straightConnector1">
@@ -5259,7 +5260,7 @@
         </p:nvCxnSpPr>
         <p:spPr>
           <a:xfrm rot="5400000">
-            <a:off x="9913283" y="2592468"/>
+            <a:off x="5120057" y="3418377"/>
             <a:ext cx="1289531" cy="2106084"/>
           </a:xfrm>
           <a:prstGeom prst="bentConnector3">
@@ -5275,6 +5276,143 @@
             <a:prstDash val="solid"/>
             <a:miter lim="800000"/>
             <a:tailEnd type="triangle"/>
+          </a:ln>
+          <a:effectLst/>
+        </p:spPr>
+      </p:cxnSp>
+      <p:sp>
+        <p:nvSpPr>
+          <p:cNvPr id="5" name="Abgerundetes Rechteck 1">
+            <a:extLst>
+              <a:ext uri="{FF2B5EF4-FFF2-40B4-BE49-F238E27FC236}">
+                <a16:creationId xmlns:a16="http://schemas.microsoft.com/office/drawing/2014/main" id="{16CB4612-BCB1-A6DF-59CB-794258BA362B}"/>
+              </a:ext>
+            </a:extLst>
+          </p:cNvPr>
+          <p:cNvSpPr/>
+          <p:nvPr/>
+        </p:nvSpPr>
+        <p:spPr>
+          <a:xfrm>
+            <a:off x="4064944" y="3737872"/>
+            <a:ext cx="537299" cy="445572"/>
+          </a:xfrm>
+          <a:prstGeom prst="roundRect">
+            <a:avLst/>
+          </a:prstGeom>
+          <a:solidFill>
+            <a:sysClr val="window" lastClr="FFFFFF">
+              <a:lumMod val="65000"/>
+            </a:sysClr>
+          </a:solidFill>
+          <a:ln w="12700" cap="flat" cmpd="sng" algn="ctr">
+            <a:solidFill>
+              <a:sysClr val="window" lastClr="FFFFFF">
+                <a:lumMod val="50000"/>
+              </a:sysClr>
+            </a:solidFill>
+            <a:prstDash val="solid"/>
+            <a:miter lim="800000"/>
+          </a:ln>
+          <a:effectLst>
+            <a:outerShdw blurRad="50800" dist="38100" dir="2700000" algn="tl" rotWithShape="0">
+              <a:prstClr val="black">
+                <a:alpha val="40000"/>
+              </a:prstClr>
+            </a:outerShdw>
+          </a:effectLst>
+        </p:spPr>
+        <p:txBody>
+          <a:bodyPr rtlCol="0" anchor="ctr"/>
+          <a:lstStyle/>
+          <a:p>
+            <a:pPr algn="ctr" defTabSz="914400">
+              <a:defRPr/>
+            </a:pPr>
+            <a:r>
+              <a:rPr lang="de-DE" sz="1050" kern="0">
+                <a:solidFill>
+                  <a:prstClr val="white"/>
+                </a:solidFill>
+                <a:latin typeface="Calibri" panose="020F0502020204030204"/>
+              </a:rPr>
+              <a:t>FC</a:t>
+            </a:r>
+            <a:endParaRPr lang="de-DE" sz="1050" kern="0" dirty="0">
+              <a:solidFill>
+                <a:prstClr val="white"/>
+              </a:solidFill>
+              <a:latin typeface="Calibri" panose="020F0502020204030204"/>
+            </a:endParaRPr>
+          </a:p>
+        </p:txBody>
+      </p:sp>
+      <p:cxnSp>
+        <p:nvCxnSpPr>
+          <p:cNvPr id="15" name="Gerade Verbindung mit Pfeil 14">
+            <a:extLst>
+              <a:ext uri="{FF2B5EF4-FFF2-40B4-BE49-F238E27FC236}">
+                <a16:creationId xmlns:a16="http://schemas.microsoft.com/office/drawing/2014/main" id="{EBEA8A2B-B8AA-E95F-B632-8E402E9B8AD7}"/>
+              </a:ext>
+            </a:extLst>
+          </p:cNvPr>
+          <p:cNvCxnSpPr>
+            <a:stCxn id="5" idx="3"/>
+            <a:endCxn id="216" idx="0"/>
+          </p:cNvCxnSpPr>
+          <p:nvPr/>
+        </p:nvCxnSpPr>
+        <p:spPr>
+          <a:xfrm>
+            <a:off x="4602243" y="3960658"/>
+            <a:ext cx="2215620" cy="980188"/>
+          </a:xfrm>
+          <a:prstGeom prst="straightConnector1">
+            <a:avLst/>
+          </a:prstGeom>
+          <a:noFill/>
+          <a:ln w="6350" cap="flat" cmpd="sng" algn="ctr">
+            <a:solidFill>
+              <a:srgbClr val="5B9BD5"/>
+            </a:solidFill>
+            <a:prstDash val="sysDash"/>
+            <a:miter lim="800000"/>
+            <a:tailEnd type="arrow"/>
+          </a:ln>
+          <a:effectLst/>
+        </p:spPr>
+      </p:cxnSp>
+      <p:cxnSp>
+        <p:nvCxnSpPr>
+          <p:cNvPr id="16" name="Gerade Verbindung mit Pfeil 15">
+            <a:extLst>
+              <a:ext uri="{FF2B5EF4-FFF2-40B4-BE49-F238E27FC236}">
+                <a16:creationId xmlns:a16="http://schemas.microsoft.com/office/drawing/2014/main" id="{0A85ACDB-25C3-D368-D668-4EAE1E2902B0}"/>
+              </a:ext>
+            </a:extLst>
+          </p:cNvPr>
+          <p:cNvCxnSpPr>
+            <a:cxnSpLocks/>
+            <a:stCxn id="5" idx="2"/>
+          </p:cNvCxnSpPr>
+          <p:nvPr/>
+        </p:nvCxnSpPr>
+        <p:spPr>
+          <a:xfrm>
+            <a:off x="4333594" y="4183444"/>
+            <a:ext cx="268649" cy="980188"/>
+          </a:xfrm>
+          <a:prstGeom prst="straightConnector1">
+            <a:avLst/>
+          </a:prstGeom>
+          <a:noFill/>
+          <a:ln w="6350" cap="flat" cmpd="sng" algn="ctr">
+            <a:solidFill>
+              <a:srgbClr val="5B9BD5"/>
+            </a:solidFill>
+            <a:prstDash val="sysDash"/>
+            <a:miter lim="800000"/>
+            <a:tailEnd type="arrow"/>
           </a:ln>
           <a:effectLst/>
         </p:spPr>
@@ -12262,6 +12400,722 @@
     <p:extLst>
       <p:ext uri="{BB962C8B-B14F-4D97-AF65-F5344CB8AC3E}">
         <p14:creationId xmlns:p14="http://schemas.microsoft.com/office/powerpoint/2010/main" val="1839067590"/>
+      </p:ext>
+    </p:extLst>
+  </p:cSld>
+  <p:clrMapOvr>
+    <a:masterClrMapping/>
+  </p:clrMapOvr>
+</p:sld>
+</file>
+
+<file path=ppt/slides/slide5.xml><?xml version="1.0" encoding="utf-8"?>
+<p:sld xmlns:a="http://schemas.openxmlformats.org/drawingml/2006/main" xmlns:r="http://schemas.openxmlformats.org/officeDocument/2006/relationships" xmlns:p="http://schemas.openxmlformats.org/presentationml/2006/main">
+  <p:cSld>
+    <p:spTree>
+      <p:nvGrpSpPr>
+        <p:cNvPr id="1" name=""/>
+        <p:cNvGrpSpPr/>
+        <p:nvPr/>
+      </p:nvGrpSpPr>
+      <p:grpSpPr>
+        <a:xfrm>
+          <a:off x="0" y="0"/>
+          <a:ext cx="0" cy="0"/>
+          <a:chOff x="0" y="0"/>
+          <a:chExt cx="0" cy="0"/>
+        </a:xfrm>
+      </p:grpSpPr>
+      <p:sp>
+        <p:nvSpPr>
+          <p:cNvPr id="2" name="Pfeil: nach rechts 1">
+            <a:extLst>
+              <a:ext uri="{FF2B5EF4-FFF2-40B4-BE49-F238E27FC236}">
+                <a16:creationId xmlns:a16="http://schemas.microsoft.com/office/drawing/2014/main" id="{4C4CC439-6463-F6FA-39DB-A8ECC280B654}"/>
+              </a:ext>
+            </a:extLst>
+          </p:cNvPr>
+          <p:cNvSpPr/>
+          <p:nvPr/>
+        </p:nvSpPr>
+        <p:spPr>
+          <a:xfrm>
+            <a:off x="1684020" y="784860"/>
+            <a:ext cx="1714500" cy="289560"/>
+          </a:xfrm>
+          <a:prstGeom prst="rightArrow">
+            <a:avLst/>
+          </a:prstGeom>
+        </p:spPr>
+        <p:style>
+          <a:lnRef idx="2">
+            <a:schemeClr val="accent1">
+              <a:shade val="15000"/>
+            </a:schemeClr>
+          </a:lnRef>
+          <a:fillRef idx="1">
+            <a:schemeClr val="accent1"/>
+          </a:fillRef>
+          <a:effectRef idx="0">
+            <a:schemeClr val="accent1"/>
+          </a:effectRef>
+          <a:fontRef idx="minor">
+            <a:schemeClr val="lt1"/>
+          </a:fontRef>
+        </p:style>
+        <p:txBody>
+          <a:bodyPr rtlCol="0" anchor="ctr"/>
+          <a:lstStyle/>
+          <a:p>
+            <a:pPr algn="ctr"/>
+            <a:endParaRPr lang="de-DE" sz="1100"/>
+          </a:p>
+        </p:txBody>
+      </p:sp>
+      <p:sp>
+        <p:nvSpPr>
+          <p:cNvPr id="4" name="Textfeld 3">
+            <a:extLst>
+              <a:ext uri="{FF2B5EF4-FFF2-40B4-BE49-F238E27FC236}">
+                <a16:creationId xmlns:a16="http://schemas.microsoft.com/office/drawing/2014/main" id="{C9C12F62-62FE-AA99-2D4E-6881D23EE35E}"/>
+              </a:ext>
+            </a:extLst>
+          </p:cNvPr>
+          <p:cNvSpPr txBox="1"/>
+          <p:nvPr/>
+        </p:nvSpPr>
+        <p:spPr>
+          <a:xfrm>
+            <a:off x="7505700" y="268300"/>
+            <a:ext cx="2110740" cy="273152"/>
+          </a:xfrm>
+          <a:prstGeom prst="rect">
+            <a:avLst/>
+          </a:prstGeom>
+          <a:noFill/>
+        </p:spPr>
+        <p:txBody>
+          <a:bodyPr wrap="square">
+            <a:spAutoFit/>
+          </a:bodyPr>
+          <a:lstStyle/>
+          <a:p>
+            <a:pPr>
+              <a:lnSpc>
+                <a:spcPts val="1425"/>
+              </a:lnSpc>
+            </a:pPr>
+            <a:r>
+              <a:rPr lang="de-DE" sz="1100" b="1">
+                <a:solidFill>
+                  <a:srgbClr val="800000"/>
+                </a:solidFill>
+                <a:effectLst/>
+                <a:latin typeface="Consolas" panose="020B0609020204030204" pitchFamily="49" charset="0"/>
+              </a:rPr>
+              <a:t>Interpretation</a:t>
+            </a:r>
+            <a:endParaRPr lang="de-DE" sz="1100" b="0">
+              <a:solidFill>
+                <a:srgbClr val="000000"/>
+              </a:solidFill>
+              <a:effectLst/>
+              <a:latin typeface="Consolas" panose="020B0609020204030204" pitchFamily="49" charset="0"/>
+            </a:endParaRPr>
+          </a:p>
+        </p:txBody>
+      </p:sp>
+      <p:sp>
+        <p:nvSpPr>
+          <p:cNvPr id="8" name="Textfeld 7">
+            <a:extLst>
+              <a:ext uri="{FF2B5EF4-FFF2-40B4-BE49-F238E27FC236}">
+                <a16:creationId xmlns:a16="http://schemas.microsoft.com/office/drawing/2014/main" id="{07572A14-6FE2-CF4D-7E35-C8906EE5E48C}"/>
+              </a:ext>
+            </a:extLst>
+          </p:cNvPr>
+          <p:cNvSpPr txBox="1"/>
+          <p:nvPr/>
+        </p:nvSpPr>
+        <p:spPr>
+          <a:xfrm>
+            <a:off x="3398520" y="828980"/>
+            <a:ext cx="4491990" cy="273152"/>
+          </a:xfrm>
+          <a:prstGeom prst="rect">
+            <a:avLst/>
+          </a:prstGeom>
+          <a:noFill/>
+        </p:spPr>
+        <p:txBody>
+          <a:bodyPr wrap="square">
+            <a:spAutoFit/>
+          </a:bodyPr>
+          <a:lstStyle/>
+          <a:p>
+            <a:pPr>
+              <a:lnSpc>
+                <a:spcPts val="1425"/>
+              </a:lnSpc>
+            </a:pPr>
+            <a:r>
+              <a:rPr lang="de-DE" sz="1100" b="0">
+                <a:solidFill>
+                  <a:srgbClr val="000000"/>
+                </a:solidFill>
+                <a:effectLst/>
+                <a:latin typeface="Consolas" panose="020B0609020204030204" pitchFamily="49" charset="0"/>
+              </a:rPr>
+              <a:t>/v1/remove-planned-microwave-link</a:t>
+            </a:r>
+          </a:p>
+        </p:txBody>
+      </p:sp>
+      <p:sp>
+        <p:nvSpPr>
+          <p:cNvPr id="9" name="Textfeld 8">
+            <a:extLst>
+              <a:ext uri="{FF2B5EF4-FFF2-40B4-BE49-F238E27FC236}">
+                <a16:creationId xmlns:a16="http://schemas.microsoft.com/office/drawing/2014/main" id="{18959C0D-EC49-453D-3DDB-DAC90831F584}"/>
+              </a:ext>
+            </a:extLst>
+          </p:cNvPr>
+          <p:cNvSpPr txBox="1"/>
+          <p:nvPr/>
+        </p:nvSpPr>
+        <p:spPr>
+          <a:xfrm>
+            <a:off x="8450580" y="705088"/>
+            <a:ext cx="2327881" cy="261610"/>
+          </a:xfrm>
+          <a:prstGeom prst="rect">
+            <a:avLst/>
+          </a:prstGeom>
+          <a:noFill/>
+        </p:spPr>
+        <p:txBody>
+          <a:bodyPr wrap="none" rtlCol="0">
+            <a:spAutoFit/>
+          </a:bodyPr>
+          <a:lstStyle/>
+          <a:p>
+            <a:r>
+              <a:rPr lang="de-DE" sz="1100"/>
+              <a:t>Deletes Link object from Candidate</a:t>
+            </a:r>
+          </a:p>
+        </p:txBody>
+      </p:sp>
+      <p:sp>
+        <p:nvSpPr>
+          <p:cNvPr id="11" name="Textfeld 10">
+            <a:extLst>
+              <a:ext uri="{FF2B5EF4-FFF2-40B4-BE49-F238E27FC236}">
+                <a16:creationId xmlns:a16="http://schemas.microsoft.com/office/drawing/2014/main" id="{64F8D2DE-D903-9367-7B09-F26182553439}"/>
+              </a:ext>
+            </a:extLst>
+          </p:cNvPr>
+          <p:cNvSpPr txBox="1"/>
+          <p:nvPr/>
+        </p:nvSpPr>
+        <p:spPr>
+          <a:xfrm>
+            <a:off x="7505700" y="1074420"/>
+            <a:ext cx="2714625" cy="273152"/>
+          </a:xfrm>
+          <a:prstGeom prst="rect">
+            <a:avLst/>
+          </a:prstGeom>
+          <a:noFill/>
+        </p:spPr>
+        <p:txBody>
+          <a:bodyPr wrap="square">
+            <a:spAutoFit/>
+          </a:bodyPr>
+          <a:lstStyle/>
+          <a:p>
+            <a:pPr>
+              <a:lnSpc>
+                <a:spcPts val="1425"/>
+              </a:lnSpc>
+            </a:pPr>
+            <a:r>
+              <a:rPr lang="de-DE" sz="1100" b="1">
+                <a:solidFill>
+                  <a:srgbClr val="800000"/>
+                </a:solidFill>
+                <a:effectLst/>
+                <a:latin typeface="Consolas" panose="020B0609020204030204" pitchFamily="49" charset="0"/>
+              </a:rPr>
+              <a:t>Validation</a:t>
+            </a:r>
+            <a:endParaRPr lang="de-DE" sz="1100" b="0">
+              <a:solidFill>
+                <a:srgbClr val="000000"/>
+              </a:solidFill>
+              <a:effectLst/>
+              <a:latin typeface="Consolas" panose="020B0609020204030204" pitchFamily="49" charset="0"/>
+            </a:endParaRPr>
+          </a:p>
+        </p:txBody>
+      </p:sp>
+      <p:sp>
+        <p:nvSpPr>
+          <p:cNvPr id="12" name="Textfeld 11">
+            <a:extLst>
+              <a:ext uri="{FF2B5EF4-FFF2-40B4-BE49-F238E27FC236}">
+                <a16:creationId xmlns:a16="http://schemas.microsoft.com/office/drawing/2014/main" id="{28C3902C-0F8D-C63F-B9B4-002B46D94C39}"/>
+              </a:ext>
+            </a:extLst>
+          </p:cNvPr>
+          <p:cNvSpPr txBox="1"/>
+          <p:nvPr/>
+        </p:nvSpPr>
+        <p:spPr>
+          <a:xfrm>
+            <a:off x="8561070" y="1594180"/>
+            <a:ext cx="1664238" cy="261610"/>
+          </a:xfrm>
+          <a:prstGeom prst="rect">
+            <a:avLst/>
+          </a:prstGeom>
+          <a:noFill/>
+        </p:spPr>
+        <p:txBody>
+          <a:bodyPr wrap="none" rtlCol="0">
+            <a:spAutoFit/>
+          </a:bodyPr>
+          <a:lstStyle/>
+          <a:p>
+            <a:r>
+              <a:rPr lang="de-DE" sz="1100"/>
+              <a:t>Maybe no validation test</a:t>
+            </a:r>
+          </a:p>
+        </p:txBody>
+      </p:sp>
+      <p:sp>
+        <p:nvSpPr>
+          <p:cNvPr id="13" name="Textfeld 12">
+            <a:extLst>
+              <a:ext uri="{FF2B5EF4-FFF2-40B4-BE49-F238E27FC236}">
+                <a16:creationId xmlns:a16="http://schemas.microsoft.com/office/drawing/2014/main" id="{B4BFC648-8762-C533-635C-0055599EF5AE}"/>
+              </a:ext>
+            </a:extLst>
+          </p:cNvPr>
+          <p:cNvSpPr txBox="1"/>
+          <p:nvPr/>
+        </p:nvSpPr>
+        <p:spPr>
+          <a:xfrm>
+            <a:off x="8561070" y="2171604"/>
+            <a:ext cx="3600666" cy="261610"/>
+          </a:xfrm>
+          <a:prstGeom prst="rect">
+            <a:avLst/>
+          </a:prstGeom>
+          <a:noFill/>
+        </p:spPr>
+        <p:txBody>
+          <a:bodyPr wrap="none" rtlCol="0">
+            <a:spAutoFit/>
+          </a:bodyPr>
+          <a:lstStyle/>
+          <a:p>
+            <a:r>
+              <a:rPr lang="de-DE" sz="1100"/>
+              <a:t>Copying into Running (Deletes Link object from Running)</a:t>
+            </a:r>
+          </a:p>
+        </p:txBody>
+      </p:sp>
+      <p:cxnSp>
+        <p:nvCxnSpPr>
+          <p:cNvPr id="15" name="Gerader Verbinder 14">
+            <a:extLst>
+              <a:ext uri="{FF2B5EF4-FFF2-40B4-BE49-F238E27FC236}">
+                <a16:creationId xmlns:a16="http://schemas.microsoft.com/office/drawing/2014/main" id="{ADBED7AA-469C-7ADB-0EB2-2CCE7A579F1C}"/>
+              </a:ext>
+            </a:extLst>
+          </p:cNvPr>
+          <p:cNvCxnSpPr/>
+          <p:nvPr/>
+        </p:nvCxnSpPr>
+        <p:spPr>
+          <a:xfrm flipH="1">
+            <a:off x="4328160" y="2689860"/>
+            <a:ext cx="7105587" cy="0"/>
+          </a:xfrm>
+          <a:prstGeom prst="line">
+            <a:avLst/>
+          </a:prstGeom>
+        </p:spPr>
+        <p:style>
+          <a:lnRef idx="2">
+            <a:schemeClr val="accent1"/>
+          </a:lnRef>
+          <a:fillRef idx="0">
+            <a:schemeClr val="accent1"/>
+          </a:fillRef>
+          <a:effectRef idx="1">
+            <a:schemeClr val="accent1"/>
+          </a:effectRef>
+          <a:fontRef idx="minor">
+            <a:schemeClr val="tx1"/>
+          </a:fontRef>
+        </p:style>
+      </p:cxnSp>
+      <p:sp>
+        <p:nvSpPr>
+          <p:cNvPr id="16" name="Textfeld 15">
+            <a:extLst>
+              <a:ext uri="{FF2B5EF4-FFF2-40B4-BE49-F238E27FC236}">
+                <a16:creationId xmlns:a16="http://schemas.microsoft.com/office/drawing/2014/main" id="{6FAED6F7-00F3-6D6B-CEE6-F561E3CF98BD}"/>
+              </a:ext>
+            </a:extLst>
+          </p:cNvPr>
+          <p:cNvSpPr txBox="1"/>
+          <p:nvPr/>
+        </p:nvSpPr>
+        <p:spPr>
+          <a:xfrm>
+            <a:off x="7396969" y="2617040"/>
+            <a:ext cx="898003" cy="215444"/>
+          </a:xfrm>
+          <a:prstGeom prst="rect">
+            <a:avLst/>
+          </a:prstGeom>
+          <a:noFill/>
+        </p:spPr>
+        <p:txBody>
+          <a:bodyPr wrap="none" rtlCol="0">
+            <a:spAutoFit/>
+          </a:bodyPr>
+          <a:lstStyle/>
+          <a:p>
+            <a:r>
+              <a:rPr lang="de-DE" sz="800"/>
+              <a:t>somewhen later</a:t>
+            </a:r>
+          </a:p>
+        </p:txBody>
+      </p:sp>
+      <p:sp>
+        <p:nvSpPr>
+          <p:cNvPr id="18" name="Textfeld 17">
+            <a:extLst>
+              <a:ext uri="{FF2B5EF4-FFF2-40B4-BE49-F238E27FC236}">
+                <a16:creationId xmlns:a16="http://schemas.microsoft.com/office/drawing/2014/main" id="{6AE4A20A-5B88-6849-2B78-06E1B3234EAF}"/>
+              </a:ext>
+            </a:extLst>
+          </p:cNvPr>
+          <p:cNvSpPr txBox="1"/>
+          <p:nvPr/>
+        </p:nvSpPr>
+        <p:spPr>
+          <a:xfrm>
+            <a:off x="8561070" y="3363704"/>
+            <a:ext cx="3667125" cy="273152"/>
+          </a:xfrm>
+          <a:prstGeom prst="rect">
+            <a:avLst/>
+          </a:prstGeom>
+          <a:noFill/>
+        </p:spPr>
+        <p:txBody>
+          <a:bodyPr wrap="square">
+            <a:spAutoFit/>
+          </a:bodyPr>
+          <a:lstStyle/>
+          <a:p>
+            <a:pPr>
+              <a:lnSpc>
+                <a:spcPts val="1425"/>
+              </a:lnSpc>
+            </a:pPr>
+            <a:r>
+              <a:rPr lang="en-US" sz="1100" b="0">
+                <a:solidFill>
+                  <a:srgbClr val="000000"/>
+                </a:solidFill>
+                <a:effectLst/>
+                <a:latin typeface="Consolas" panose="020B0609020204030204" pitchFamily="49" charset="0"/>
+              </a:rPr>
+              <a:t>Read device data from MWDI</a:t>
+            </a:r>
+          </a:p>
+        </p:txBody>
+      </p:sp>
+      <p:sp>
+        <p:nvSpPr>
+          <p:cNvPr id="20" name="Textfeld 19">
+            <a:extLst>
+              <a:ext uri="{FF2B5EF4-FFF2-40B4-BE49-F238E27FC236}">
+                <a16:creationId xmlns:a16="http://schemas.microsoft.com/office/drawing/2014/main" id="{BB8B16F5-8550-484E-5A90-17C3A2A2247B}"/>
+              </a:ext>
+            </a:extLst>
+          </p:cNvPr>
+          <p:cNvSpPr txBox="1"/>
+          <p:nvPr/>
+        </p:nvSpPr>
+        <p:spPr>
+          <a:xfrm>
+            <a:off x="8561070" y="3822698"/>
+            <a:ext cx="8012430" cy="1520031"/>
+          </a:xfrm>
+          <a:prstGeom prst="rect">
+            <a:avLst/>
+          </a:prstGeom>
+          <a:noFill/>
+        </p:spPr>
+        <p:txBody>
+          <a:bodyPr wrap="square">
+            <a:spAutoFit/>
+          </a:bodyPr>
+          <a:lstStyle/>
+          <a:p>
+            <a:pPr>
+              <a:lnSpc>
+                <a:spcPts val="1425"/>
+              </a:lnSpc>
+            </a:pPr>
+            <a:r>
+              <a:rPr lang="en-US" sz="1100" b="0">
+                <a:solidFill>
+                  <a:srgbClr val="000000"/>
+                </a:solidFill>
+                <a:effectLst/>
+                <a:latin typeface="Consolas" panose="020B0609020204030204" pitchFamily="49" charset="0"/>
+              </a:rPr>
+              <a:t>Create Link objects in OperationalDS</a:t>
+            </a:r>
+          </a:p>
+          <a:p>
+            <a:pPr>
+              <a:lnSpc>
+                <a:spcPts val="1425"/>
+              </a:lnSpc>
+            </a:pPr>
+            <a:r>
+              <a:rPr lang="en-US" sz="1100">
+                <a:solidFill>
+                  <a:srgbClr val="000000"/>
+                </a:solidFill>
+                <a:latin typeface="Consolas" panose="020B0609020204030204" pitchFamily="49" charset="0"/>
+              </a:rPr>
+              <a:t>(idempotent function. </a:t>
+            </a:r>
+          </a:p>
+          <a:p>
+            <a:pPr>
+              <a:lnSpc>
+                <a:spcPts val="1425"/>
+              </a:lnSpc>
+            </a:pPr>
+            <a:r>
+              <a:rPr lang="en-US" sz="1100">
+                <a:solidFill>
+                  <a:srgbClr val="000000"/>
+                </a:solidFill>
+                <a:latin typeface="Consolas" panose="020B0609020204030204" pitchFamily="49" charset="0"/>
+              </a:rPr>
+              <a:t>means:</a:t>
+            </a:r>
+          </a:p>
+          <a:p>
+            <a:pPr marL="171450" indent="-171450">
+              <a:lnSpc>
+                <a:spcPts val="1425"/>
+              </a:lnSpc>
+              <a:buFontTx/>
+              <a:buChar char="-"/>
+            </a:pPr>
+            <a:r>
+              <a:rPr lang="en-US" sz="1100">
+                <a:solidFill>
+                  <a:srgbClr val="000000"/>
+                </a:solidFill>
+                <a:latin typeface="Consolas" panose="020B0609020204030204" pitchFamily="49" charset="0"/>
+              </a:rPr>
+              <a:t>it calculates all potential connections =&gt; all Link objects</a:t>
+            </a:r>
+          </a:p>
+          <a:p>
+            <a:pPr marL="171450" indent="-171450">
+              <a:lnSpc>
+                <a:spcPts val="1425"/>
+              </a:lnSpc>
+              <a:buFontTx/>
+              <a:buChar char="-"/>
+            </a:pPr>
+            <a:r>
+              <a:rPr lang="en-US" sz="1100">
+                <a:solidFill>
+                  <a:srgbClr val="000000"/>
+                </a:solidFill>
+                <a:latin typeface="Consolas" panose="020B0609020204030204" pitchFamily="49" charset="0"/>
+              </a:rPr>
+              <a:t>if some Link object already exists between two AirInterfaces in OperationalDS, it does not touch it</a:t>
+            </a:r>
+          </a:p>
+          <a:p>
+            <a:pPr marL="171450" indent="-171450">
+              <a:lnSpc>
+                <a:spcPts val="1425"/>
+              </a:lnSpc>
+              <a:buFontTx/>
+              <a:buChar char="-"/>
+            </a:pPr>
+            <a:r>
+              <a:rPr lang="en-US" sz="1100">
+                <a:solidFill>
+                  <a:srgbClr val="000000"/>
+                </a:solidFill>
+                <a:latin typeface="Consolas" panose="020B0609020204030204" pitchFamily="49" charset="0"/>
+              </a:rPr>
+              <a:t>if some Link object doesn’t exist, it creates it</a:t>
+            </a:r>
+          </a:p>
+          <a:p>
+            <a:pPr>
+              <a:lnSpc>
+                <a:spcPts val="1425"/>
+              </a:lnSpc>
+            </a:pPr>
+            <a:endParaRPr lang="en-US" sz="1100" b="0">
+              <a:solidFill>
+                <a:srgbClr val="000000"/>
+              </a:solidFill>
+              <a:effectLst/>
+              <a:latin typeface="Consolas" panose="020B0609020204030204" pitchFamily="49" charset="0"/>
+            </a:endParaRPr>
+          </a:p>
+          <a:p>
+            <a:pPr>
+              <a:lnSpc>
+                <a:spcPts val="1425"/>
+              </a:lnSpc>
+            </a:pPr>
+            <a:r>
+              <a:rPr lang="en-US" sz="1100" b="0">
+                <a:solidFill>
+                  <a:srgbClr val="000000"/>
+                </a:solidFill>
+                <a:effectLst/>
+                <a:latin typeface="Consolas" panose="020B0609020204030204" pitchFamily="49" charset="0"/>
+              </a:rPr>
+              <a:t>=&gt; results in Link objects between all AirInterface LTPs that are existing on the device</a:t>
+            </a:r>
+          </a:p>
+        </p:txBody>
+      </p:sp>
+      <p:sp>
+        <p:nvSpPr>
+          <p:cNvPr id="22" name="Textfeld 21">
+            <a:extLst>
+              <a:ext uri="{FF2B5EF4-FFF2-40B4-BE49-F238E27FC236}">
+                <a16:creationId xmlns:a16="http://schemas.microsoft.com/office/drawing/2014/main" id="{594E9D90-1B16-9893-648E-AF6BEB9DC72C}"/>
+              </a:ext>
+            </a:extLst>
+          </p:cNvPr>
+          <p:cNvSpPr txBox="1"/>
+          <p:nvPr/>
+        </p:nvSpPr>
+        <p:spPr>
+          <a:xfrm>
+            <a:off x="7625715" y="2982078"/>
+            <a:ext cx="1624965" cy="286360"/>
+          </a:xfrm>
+          <a:prstGeom prst="rect">
+            <a:avLst/>
+          </a:prstGeom>
+          <a:noFill/>
+        </p:spPr>
+        <p:txBody>
+          <a:bodyPr wrap="square">
+            <a:spAutoFit/>
+          </a:bodyPr>
+          <a:lstStyle>
+            <a:defPPr>
+              <a:defRPr lang="en-US"/>
+            </a:defPPr>
+            <a:lvl1pPr>
+              <a:lnSpc>
+                <a:spcPts val="1425"/>
+              </a:lnSpc>
+              <a:defRPr sz="1100" b="1">
+                <a:solidFill>
+                  <a:srgbClr val="800000"/>
+                </a:solidFill>
+                <a:effectLst/>
+                <a:latin typeface="Consolas" panose="020B0609020204030204" pitchFamily="49" charset="0"/>
+              </a:defRPr>
+            </a:lvl1pPr>
+          </a:lstStyle>
+          <a:p>
+            <a:r>
+              <a:rPr lang="de-DE"/>
+              <a:t>Measurement</a:t>
+            </a:r>
+          </a:p>
+        </p:txBody>
+      </p:sp>
+      <p:sp>
+        <p:nvSpPr>
+          <p:cNvPr id="23" name="Denkblase: wolkenförmig 22">
+            <a:extLst>
+              <a:ext uri="{FF2B5EF4-FFF2-40B4-BE49-F238E27FC236}">
+                <a16:creationId xmlns:a16="http://schemas.microsoft.com/office/drawing/2014/main" id="{E3EF954D-C565-4070-B2AE-33B1481B495C}"/>
+              </a:ext>
+            </a:extLst>
+          </p:cNvPr>
+          <p:cNvSpPr/>
+          <p:nvPr/>
+        </p:nvSpPr>
+        <p:spPr>
+          <a:xfrm>
+            <a:off x="13677900" y="2997313"/>
+            <a:ext cx="2659380" cy="573726"/>
+          </a:xfrm>
+          <a:prstGeom prst="cloudCallout">
+            <a:avLst>
+              <a:gd name="adj1" fmla="val -26908"/>
+              <a:gd name="adj2" fmla="val 76379"/>
+            </a:avLst>
+          </a:prstGeom>
+        </p:spPr>
+        <p:style>
+          <a:lnRef idx="2">
+            <a:schemeClr val="accent2">
+              <a:shade val="15000"/>
+            </a:schemeClr>
+          </a:lnRef>
+          <a:fillRef idx="1">
+            <a:schemeClr val="accent2"/>
+          </a:fillRef>
+          <a:effectRef idx="0">
+            <a:schemeClr val="accent2"/>
+          </a:effectRef>
+          <a:fontRef idx="minor">
+            <a:schemeClr val="lt1"/>
+          </a:fontRef>
+        </p:style>
+        <p:txBody>
+          <a:bodyPr rtlCol="0" anchor="ctr"/>
+          <a:lstStyle/>
+          <a:p>
+            <a:pPr algn="ctr"/>
+            <a:r>
+              <a:rPr lang="de-DE" sz="800"/>
+              <a:t>Which pairs of CCs have  to be considdered while creating the Link objects?</a:t>
+            </a:r>
+          </a:p>
+        </p:txBody>
+      </p:sp>
+    </p:spTree>
+    <p:extLst>
+      <p:ext uri="{BB962C8B-B14F-4D97-AF65-F5344CB8AC3E}">
+        <p14:creationId xmlns:p14="http://schemas.microsoft.com/office/powerpoint/2010/main" val="1937595810"/>
       </p:ext>
     </p:extLst>
   </p:cSld>

</xml_diff>